<commit_message>
P115/meeting: revise meeting deck in the research voice
</commit_message>
<xml_diff>
--- a/docs/TEAM_MEETING_DECK.pptx
+++ b/docs/TEAM_MEETING_DECK.pptx
@@ -2,20 +2,20 @@
 <file path=ppt/presentation.xml><?xml version="1.0" encoding="utf-8"?>
 <p:presentation xmlns:p="http://schemas.openxmlformats.org/presentationml/2006/main">
   <p:sldMasterIdLst>
-    <p:sldMasterId xmlns:r="http://schemas.openxmlformats.org/officeDocument/2006/relationships" id="2147483648" r:id="R845894cdc0dc467e"/>
+    <p:sldMasterId xmlns:r="http://schemas.openxmlformats.org/officeDocument/2006/relationships" id="2147483648" r:id="Rd0e4da75f2834eaa"/>
   </p:sldMasterIdLst>
   <p:notesMasterIdLst>
-    <p:notesMasterId xmlns:r="http://schemas.openxmlformats.org/officeDocument/2006/relationships" r:id="R3a76741a1db44feb"/>
+    <p:notesMasterId xmlns:r="http://schemas.openxmlformats.org/officeDocument/2006/relationships" r:id="R547a9c2cb6324424"/>
   </p:notesMasterIdLst>
   <p:sldIdLst>
-    <p:sldId xmlns:r="http://schemas.openxmlformats.org/officeDocument/2006/relationships" id="256" r:id="Rf09f52ba60774289"/>
-    <p:sldId xmlns:r="http://schemas.openxmlformats.org/officeDocument/2006/relationships" id="257" r:id="R674a691772814ee7"/>
-    <p:sldId xmlns:r="http://schemas.openxmlformats.org/officeDocument/2006/relationships" id="258" r:id="R97a75c618902442f"/>
-    <p:sldId xmlns:r="http://schemas.openxmlformats.org/officeDocument/2006/relationships" id="259" r:id="Rdfd8bac1707e4400"/>
-    <p:sldId xmlns:r="http://schemas.openxmlformats.org/officeDocument/2006/relationships" id="260" r:id="R165bc53145854a84"/>
-    <p:sldId xmlns:r="http://schemas.openxmlformats.org/officeDocument/2006/relationships" id="261" r:id="R2c261407cefc45d3"/>
-    <p:sldId xmlns:r="http://schemas.openxmlformats.org/officeDocument/2006/relationships" id="262" r:id="R3667a2cc9cea4c4d"/>
-    <p:sldId xmlns:r="http://schemas.openxmlformats.org/officeDocument/2006/relationships" id="263" r:id="R4c604f48cddd4c9f"/>
+    <p:sldId xmlns:r="http://schemas.openxmlformats.org/officeDocument/2006/relationships" id="256" r:id="R4b01f73389c94e02"/>
+    <p:sldId xmlns:r="http://schemas.openxmlformats.org/officeDocument/2006/relationships" id="257" r:id="R53750ff584394ec2"/>
+    <p:sldId xmlns:r="http://schemas.openxmlformats.org/officeDocument/2006/relationships" id="258" r:id="Rb36081c35de24645"/>
+    <p:sldId xmlns:r="http://schemas.openxmlformats.org/officeDocument/2006/relationships" id="259" r:id="Rcdcf3c1ce0d642d7"/>
+    <p:sldId xmlns:r="http://schemas.openxmlformats.org/officeDocument/2006/relationships" id="260" r:id="R0b85fcb3fa334ab0"/>
+    <p:sldId xmlns:r="http://schemas.openxmlformats.org/officeDocument/2006/relationships" id="261" r:id="R09b26ff003dc4bbe"/>
+    <p:sldId xmlns:r="http://schemas.openxmlformats.org/officeDocument/2006/relationships" id="262" r:id="Rc9cb0478818a403a"/>
+    <p:sldId xmlns:r="http://schemas.openxmlformats.org/officeDocument/2006/relationships" id="263" r:id="Rfc7f34ac9d7349f6"/>
   </p:sldIdLst>
   <p:sldSz cx="12192000" cy="6858000"/>
   <p:notesSz cx="6858000" cy="9144000"/>
@@ -449,7 +449,12 @@
           <a:lstStyle xmlns:a="http://schemas.openxmlformats.org/drawingml/2006/main"/>
           <a:p xmlns:a="http://schemas.openxmlformats.org/drawingml/2006/main">
             <a:r>
-              <a:t>开场0–4分钟：每人介绍姓名、背景和感兴趣的工作线。现状4–8分钟：原型已有，会议重点是将产品与研究组织成可交付的共同工作。所有状态指源码；已安装或正在运行的Hub不因此自动升级。PR33为桌面Phase A，已于2026-09-13合入；独立分发及干净环境验收仍为后续工作。</a:t>
+              <a:t>开场先请各位介绍背景和感兴趣的方向，约4分钟。随后用4分钟说明当前进展。MonkeyHub 已连接主要工作界面，本地建模可以先连续编辑草稿，再手动同步为候选。白板上的批注和选中文字可以带回设计反馈。CAD 接口和 Hub 执行管理已有初步实现，Windows 桌面入口 Phase A 已合入 main。</a:t>
+            </a:r>
+          </a:p>
+          <a:p xmlns:a="http://schemas.openxmlformats.org/drawingml/2006/main">
+            <a:r>
+              <a:t>这些是源码进展，完整独立打包和干净机器上的安装检查仍有后续工作。</a:t>
             </a:r>
           </a:p>
           <a:p xmlns:a="http://schemas.openxmlformats.org/drawingml/2006/main">
@@ -544,7 +549,12 @@
           <a:lstStyle xmlns:a="http://schemas.openxmlformats.org/drawingml/2006/main"/>
           <a:p xmlns:a="http://schemas.openxmlformats.org/drawingml/2006/main">
             <a:r>
-              <a:t>8–11分钟：人、通用Agent和生成器都可以参与生成或修改。ArchFlow保留身份、依赖、来源和版本；运行时负责操作、工作进程、恢复与投影；具体工具执行或呈现结果。图中从意图到执行的箭头是职责关系，不表示任意语义请求已全部自动实现。产品界面为MonkeyArch、Board、Diagram、Fab、Monitor，Hub组合这些界面。</a:t>
+              <a:t>这部分约3分钟，说明项目记录与具体工具的关系。人、通用 Agent 和生成器都可以参与设计修改。ArchFlow 保存对象身份、依赖、来源和版本，运行时调度操作与工作进程，并处理任务恢复和模型投影。具体工具承担计算和呈现。换用工具后，设计仍在同一项目记录上继续。</a:t>
+            </a:r>
+          </a:p>
+          <a:p xmlns:a="http://schemas.openxmlformats.org/drawingml/2006/main">
+            <a:r>
+              <a:t>图示说明职责分配。自然语言意图仍需通过已有接口转为可执行动作，图中的连接不表示任意请求都已实现。</a:t>
             </a:r>
           </a:p>
           <a:p xmlns:a="http://schemas.openxmlformats.org/drawingml/2006/main">
@@ -624,7 +634,7 @@
           <a:lstStyle xmlns:a="http://schemas.openxmlformats.org/drawingml/2006/main"/>
           <a:p xmlns:a="http://schemas.openxmlformats.org/drawingml/2006/main">
             <a:r>
-              <a:t>11–24分钟：每条线约三分钟。负责人在会上确定，不预设人名。Paper整理研究问题、协议与比较；Blender实现同一项目的场景投影与渲染；Interaction负责本地直接操作；Backend先让真实设计回合可观测，再减少Agent轮次。四条线以现有公共契约协作。</a:t>
+              <a:t>接下来四组各讨论约3分钟，负责人在会上认领。Paper 整理研究问题与比较方法。Blender 完成场景生成、渲染和修改后的更新。Interaction 在已有指针操作上完善连续编辑与吸附。Backend 先记录完整设计任务，再研究减少模型调用的方法。各组说明近期成果和负责范围。涉及共用接口时，将接口修改单独提交，供相关组继续工作。</a:t>
             </a:r>
           </a:p>
           <a:p xmlns:a="http://schemas.openxmlformats.org/drawingml/2006/main">
@@ -704,7 +714,22 @@
           <a:lstStyle xmlns:a="http://schemas.openxmlformats.org/drawingml/2006/main"/>
           <a:p xmlns:a="http://schemas.openxmlformats.org/drawingml/2006/main">
             <a:r>
-              <a:t>研究问题沿用会议材料，尚不是实验结论。A为直接/raw CAD Agent；B为当前ArchFlow多轮Agent；C为拟验证的编译上下文与事务运行时路径。固定真实任务、起始版本与provider/model，重复采样，比较模型轮次、读取/工具调用、tokens、首个可见结果、验证完成时间、歧义失败和连续修改漂移。首次交付先定术语与协议；两周交付为一张架构图、一个基准协议、第一张结果表与可证伪的文字主张。数据沿用Monitor，不在看到结果后改变基准规则。</a:t>
+              <a:t>研究问题来自会议材料：通用 Agent 能否将设计意图编译为类型明确的设计事务，由能够处理依赖关系的运行时执行，从而减少逐步操作 CAD 的模型轮次。</a:t>
+            </a:r>
+          </a:p>
+          <a:p xmlns:a="http://schemas.openxmlformats.org/drawingml/2006/main">
+            <a:r>
+              <a:t>比较三种方式：A 由 Agent 直接操作 CAD；B 使用当前 ArchFlow 的多轮 Agent 与工具调用；C 使用拟研究的上下文编译和事务执行方案。C 仍是实验方案。</a:t>
+            </a:r>
+          </a:p>
+          <a:p xmlns:a="http://schemas.openxmlformats.org/drawingml/2006/main">
+            <a:r>
+              <a:t>固定真实任务、起始版本及 provider/model 配置，重复运行。记录模型轮次、读取与工具调用次数、tokens、首个可见结果和验证完成时间，并观察歧义处理失败及连续修改中的漂移。实验方案在运行前确定，数据从 Monitor 读取。</a:t>
+            </a:r>
+          </a:p>
+          <a:p xmlns:a="http://schemas.openxmlformats.org/drawingml/2006/main">
+            <a:r>
+              <a:t>两周内形成研究架构图、比较实验方案和首张结果表。根据结果讨论能够接受后续检验的研究判断，具体判断由团队提出。</a:t>
             </a:r>
           </a:p>
           <a:p xmlns:a="http://schemas.openxmlformats.org/drawingml/2006/main">
@@ -784,7 +809,12 @@
           <a:lstStyle xmlns:a="http://schemas.openxmlformats.org/drawingml/2006/main"/>
           <a:p xmlns:a="http://schemas.openxmlformats.org/drawingml/2006/main">
             <a:r>
-              <a:t>复用#13已有CAD合同，做一个纵向完整演示：显式投影项目到.blend，保持语义/对象身份，映射材料与collection，建立相机和基本照明，渲染一张PNG。然后修改ArchFlow项目状态，重建或更新Blender投影，再渲染变化结果。Blender不是另一份Canonical State。优先一个可靠渲染通道；不支持的几何明确失败。资产、Geometry Nodes、动画等是这个边界未来可能承载的能力，不计入此次两周交付。</a:t>
+              <a:t>本组完成从项目到渲染、再到设计修改后更新的完整示例。复用 #13 的 CAD 接口，将项目生成原生 .blend 场景，按对象含义组织 collection 和材料，设置相机与基础照明，输出首张 PNG。随后修改 ArchFlow 项目，重新生成或更新 Blender 场景，并渲染第二张图。</a:t>
+            </a:r>
+          </a:p>
+          <a:p xmlns:a="http://schemas.openxmlformats.org/drawingml/2006/main">
+            <a:r>
+              <a:t>两次场景应保留与项目对象的对应关系，项目状态仍由 ArchFlow 管理。近期先完成一套可靠的渲染流程。Geometry Nodes、动画等扩展另行安排。</a:t>
             </a:r>
           </a:p>
           <a:p xmlns:a="http://schemas.openxmlformats.org/drawingml/2006/main">
@@ -869,7 +899,17 @@
           <a:lstStyle xmlns:a="http://schemas.openxmlformats.org/drawingml/2006/main"/>
           <a:p xmlns:a="http://schemas.openxmlformats.org/drawingml/2006/main">
             <a:r>
-              <a:t>既有本地预览、hover、Push/Pull、草稿、曲线和撤销已交付。本轮完善鼠标直接操作：选中/预选、激活工具、指针操作与本地预览、可选数值覆盖、点击或Enter结束为一个本地草稿动作。指针运动不发模型请求；完整草稿仍由用户显式Sync生成验证候选。先补当前工具所需的吸附保持和推断，只有测量证明必要才做大场景索引。分别量指针到预览、结束手势到本地确认、Sync到验证候选。</a:t>
+              <a:t>移动、复制、旋转、缩放和沿坐标轴镜像的指针操作已通过 PR #36–38 合入 main。本地预览、Push/Pull、曲线及撤销已有实现。接下来通过连续建模检查工具之间的衔接，重点改善吸附保持和当前操作需要的推断。</a:t>
+            </a:r>
+          </a:p>
+          <a:p xmlns:a="http://schemas.openxmlformats.org/drawingml/2006/main">
+            <a:r>
+              <a:t>用户选中对象后进行指针操作，可输入数值覆盖，点击或按 Enter 确认本次草稿修改。预览在本地计算，不发送模型请求。用户手动 Sync 后，系统执行整批草稿并生成验证候选。</a:t>
+            </a:r>
+          </a:p>
+          <a:p xmlns:a="http://schemas.openxmlformats.org/drawingml/2006/main">
+            <a:r>
+              <a:t>分别观察指针到预览、手势结束到草稿确认、Sync 到候选的耗时。只有实际延迟表明需要时，再做大场景索引优化。</a:t>
             </a:r>
           </a:p>
           <a:p xmlns:a="http://schemas.openxmlformats.org/drawingml/2006/main">
@@ -879,7 +919,17 @@
           </a:p>
           <a:p xmlns:a="http://schemas.openxmlformats.org/drawingml/2006/main">
             <a:r>
-              <a:t>https://github.com/cogco1/ARCHFLOW_V4/pull/28</a:t>
+              <a:t>https://github.com/cogco1/ARCHFLOW_V4/pull/36</a:t>
+            </a:r>
+          </a:p>
+          <a:p xmlns:a="http://schemas.openxmlformats.org/drawingml/2006/main">
+            <a:r>
+              <a:t>https://github.com/cogco1/ARCHFLOW_V4/pull/37</a:t>
+            </a:r>
+          </a:p>
+          <a:p xmlns:a="http://schemas.openxmlformats.org/drawingml/2006/main">
+            <a:r>
+              <a:t>https://github.com/cogco1/ARCHFLOW_V4/pull/38</a:t>
             </a:r>
           </a:p>
           <a:p xmlns:a="http://schemas.openxmlformats.org/drawingml/2006/main">
@@ -959,7 +1009,17 @@
           <a:lstStyle xmlns:a="http://schemas.openxmlformats.org/drawingml/2006/main"/>
           <a:p xmlns:a="http://schemas.openxmlformats.org/drawingml/2006/main">
             <a:r>
-              <a:t>第一优先级是#32最新Phase0：同一turn_id关联Hub、provider、Studio、candidate、CAD、verify与preview。Monitor自动显示实际测量的摘要、实时水平瀑布图、语义活动树和关键路径，识别重复读取、重试与可避免的唤醒；原始记录置于详情。时间/用量来自真实执行，不手填；价格按确切provider/model/billing配置推导，订阅CLI不可伪称按次账单；未知显示不可用或清晰标注API等价估算。第一切片不改变设计语义。之后依据同一任务的trace推进ContextPack与DesignTransaction，保留现有proposal/candidate/P036，只有真实歧义才重新唤醒Agent。图为工作顺序，未给出未经测量的秒数或收益。</a:t>
+              <a:t>先完成 #32 的任务记录和 Monitor 展示。使用同一 turn_id 关联 Hub、provider、Studio、candidate、CAD、验证与预览。Monitor 用水平时间图、按活动含义分组的记录和关键路径，展示时间花在哪里，帮助辨认重复读取、重试和可以省去的模型唤醒。</a:t>
+            </a:r>
+          </a:p>
+          <a:p xmlns:a="http://schemas.openxmlformats.org/drawingml/2006/main">
+            <a:r>
+              <a:t>用量和时间从实际执行自动采集。费用依据确切的 provider、model 和计费配置计算。订阅 CLI 的 API 等价估算应注明估算，不能表示为账户实际扣款；价格依据不足时不显示确定费用。</a:t>
+            </a:r>
+          </a:p>
+          <a:p xmlns:a="http://schemas.openxmlformats.org/drawingml/2006/main">
+            <a:r>
+              <a:t>随后用同一任务研究 ContextPack 与 DesignTransaction：汇集判断所需信息，将修改组织为事务，由运行时执行并读回。出现需要重新判断的歧义时，再调用 Agent。保留现有 proposal、candidate 和 P036 的项目保存方式，任务记录不成为另一份项目状态。</a:t>
             </a:r>
           </a:p>
           <a:p xmlns:a="http://schemas.openxmlformats.org/drawingml/2006/main">
@@ -1044,7 +1104,17 @@
           <a:lstStyle xmlns:a="http://schemas.openxmlformats.org/drawingml/2006/main"/>
           <a:p xmlns:a="http://schemas.openxmlformats.org/drawingml/2006/main">
             <a:r>
-              <a:t>24–30分钟：main是共同事实；每个任务一个lane/branch/worktree/PR，先执行python tools/devctl.py work并查看目标owner/contract；不吸收他人未合入WIP，共享契约以小PR先行。每条线离会前口头确认：Track、Owner、Base main SHA、Issue/lane、首个交付物、预期文件/modules、Tests/benchmark、Blocked by。只安排Paper/Blender/Interaction/Backend四条线。Board协作、桌面完整打包、更广的runtime恢复、Diagram/Fab扩展等只作为未来方向，不自动派入本次两周任务。</a:t>
+              <a:t>最后约6分钟确定分工。每组从 main 建立独立 branch 和 worktree，用现有 lane 登记任务，通过 PR 评审后合入。开始前运行 python tools/devctl.py work，查看正在进行的工作及目标模块的职责和接口，避免覆盖其他组未合入的修改。</a:t>
+            </a:r>
+          </a:p>
+          <a:p xmlns:a="http://schemas.openxmlformats.org/drawingml/2006/main">
+            <a:r>
+              <a:t>负责人说明对应 issue/lane、起始 main 版本、首个 PR 或研究材料、预计涉及的文件与模块、检查方法，以及需要其他组先完成的工作。</a:t>
+            </a:r>
+          </a:p>
+          <a:p xmlns:a="http://schemas.openxmlformats.org/drawingml/2006/main">
+            <a:r>
+              <a:t>本次只安排 Paper、Blender、Interaction、Backend 四组。Board 协作、桌面完整打包、任务恢复和 Diagram/Fab 扩展留作后续工作。</a:t>
             </a:r>
           </a:p>
           <a:p xmlns:a="http://schemas.openxmlformats.org/drawingml/2006/main">
@@ -1122,7 +1192,7 @@
   </p:cSld>
   <p:clrMap bg1="lt1" tx1="dk1" bg2="lt2" tx2="dk2" accent1="accent1" accent2="accent2" accent3="accent3" accent4="accent4" accent5="accent5" accent6="accent6" hlink="hlink" folHlink="folHlink"/>
   <p:sldLayoutIdLst>
-    <p:sldLayoutId xmlns:r="http://schemas.openxmlformats.org/officeDocument/2006/relationships" id="2147483649" r:id="Rd2850446442a4f20"/>
+    <p:sldLayoutId xmlns:r="http://schemas.openxmlformats.org/officeDocument/2006/relationships" id="2147483649" r:id="R862d9ab46b524d27"/>
   </p:sldLayoutIdLst>
   <p:txStyles>
     <p:titleStyle>
@@ -1702,6 +1772,7 @@
           <a:lstStyle xmlns:a="http://schemas.openxmlformats.org/drawingml/2006/main"/>
           <a:p xmlns:a="http://schemas.openxmlformats.org/drawingml/2006/main">
             <a:pPr algn="l">
+              <a:buNone/>
               <a:defRPr sz="3300" b="1">
                 <a:solidFill>
                   <a:srgbClr val="202321"/>
@@ -1720,7 +1791,7 @@
                 <a:ea typeface="Microsoft YaHei"/>
                 <a:cs typeface="Microsoft YaHei"/>
               </a:rPr>
-              <a:t>ArchFlow / Monkey 团队会议</a:t>
+              <a:t>ArchFlow / Monkey 当前进展</a:t>
             </a:r>
           </a:p>
         </p:txBody>
@@ -1759,6 +1830,7 @@
           <a:lstStyle xmlns:a="http://schemas.openxmlformats.org/drawingml/2006/main"/>
           <a:p xmlns:a="http://schemas.openxmlformats.org/drawingml/2006/main">
             <a:pPr algn="l">
+              <a:buNone/>
               <a:defRPr sz="1950" b="0">
                 <a:solidFill>
                   <a:srgbClr val="646B66"/>
@@ -1777,7 +1849,7 @@
                 <a:ea typeface="Microsoft YaHei"/>
                 <a:cs typeface="Microsoft YaHei"/>
               </a:rPr>
-              <a:t>两周协作：Paper / Blender / Interaction / Backend</a:t>
+              <a:t>两周工作安排：Paper / Blender / Interaction / Backend</a:t>
             </a:r>
           </a:p>
         </p:txBody>
@@ -1846,6 +1918,7 @@
           <a:lstStyle xmlns:a="http://schemas.openxmlformats.org/drawingml/2006/main"/>
           <a:p xmlns:a="http://schemas.openxmlformats.org/drawingml/2006/main">
             <a:pPr algn="l">
+              <a:buNone/>
               <a:defRPr sz="1200" b="0">
                 <a:solidFill>
                   <a:srgbClr val="646B66"/>
@@ -1903,6 +1976,7 @@
           <a:lstStyle xmlns:a="http://schemas.openxmlformats.org/drawingml/2006/main"/>
           <a:p xmlns:a="http://schemas.openxmlformats.org/drawingml/2006/main">
             <a:pPr algn="r">
+              <a:buNone/>
               <a:defRPr sz="1350" b="0">
                 <a:solidFill>
                   <a:srgbClr val="646B66"/>
@@ -1960,6 +2034,7 @@
           <a:lstStyle xmlns:a="http://schemas.openxmlformats.org/drawingml/2006/main"/>
           <a:p xmlns:a="http://schemas.openxmlformats.org/drawingml/2006/main">
             <a:pPr algn="l">
+              <a:buNone/>
               <a:defRPr sz="3825" b="1">
                 <a:solidFill>
                   <a:srgbClr val="202321"/>
@@ -1978,11 +2053,12 @@
                 <a:ea typeface="Microsoft YaHei"/>
                 <a:cs typeface="Microsoft YaHei"/>
               </a:rPr>
-              <a:t>原型已有</a:t>
+              <a:t>本地建模与反馈</a:t>
             </a:r>
           </a:p>
           <a:p xmlns:a="http://schemas.openxmlformats.org/drawingml/2006/main">
             <a:pPr algn="l">
+              <a:buNone/>
               <a:defRPr sz="3825" b="1">
                 <a:solidFill>
                   <a:srgbClr val="202321"/>
@@ -2001,30 +2077,7 @@
                 <a:ea typeface="Microsoft YaHei"/>
                 <a:cs typeface="Microsoft YaHei"/>
               </a:rPr>
-              <a:t>产品与研究需要</a:t>
-            </a:r>
-          </a:p>
-          <a:p xmlns:a="http://schemas.openxmlformats.org/drawingml/2006/main">
-            <a:pPr algn="l">
-              <a:defRPr sz="3825" b="1">
-                <a:solidFill>
-                  <a:srgbClr val="202321"/>
-                </a:solidFill>
-                <a:latin typeface="Microsoft YaHei"/>
-                <a:ea typeface="Microsoft YaHei"/>
-                <a:cs typeface="Microsoft YaHei"/>
-              </a:defRPr>
-            </a:pPr>
-            <a:r>
-              <a:rPr sz="3825" b="1">
-                <a:solidFill>
-                  <a:srgbClr val="202321"/>
-                </a:solidFill>
-                <a:latin typeface="Microsoft YaHei"/>
-                <a:ea typeface="Microsoft YaHei"/>
-                <a:cs typeface="Microsoft YaHei"/>
-              </a:rPr>
-              <a:t>共同的下一步</a:t>
+              <a:t>已具备基础流程</a:t>
             </a:r>
           </a:p>
         </p:txBody>
@@ -2093,6 +2146,7 @@
           <a:lstStyle xmlns:a="http://schemas.openxmlformats.org/drawingml/2006/main"/>
           <a:p xmlns:a="http://schemas.openxmlformats.org/drawingml/2006/main">
             <a:pPr algn="l">
+              <a:buNone/>
               <a:defRPr sz="1875" b="1">
                 <a:solidFill>
                   <a:srgbClr val="B74736"/>
@@ -2150,6 +2204,7 @@
           <a:lstStyle xmlns:a="http://schemas.openxmlformats.org/drawingml/2006/main"/>
           <a:p xmlns:a="http://schemas.openxmlformats.org/drawingml/2006/main">
             <a:pPr algn="l">
+              <a:buNone/>
               <a:defRPr sz="1875" b="0">
                 <a:solidFill>
                   <a:srgbClr val="202321"/>
@@ -2168,7 +2223,7 @@
                 <a:ea typeface="Microsoft YaHei"/>
                 <a:cs typeface="Microsoft YaHei"/>
               </a:rPr>
-              <a:t>本地草稿与手动 Sync</a:t>
+              <a:t>本地编辑草稿，手动同步候选</a:t>
             </a:r>
           </a:p>
         </p:txBody>
@@ -2237,6 +2292,7 @@
           <a:lstStyle xmlns:a="http://schemas.openxmlformats.org/drawingml/2006/main"/>
           <a:p xmlns:a="http://schemas.openxmlformats.org/drawingml/2006/main">
             <a:pPr algn="l">
+              <a:buNone/>
               <a:defRPr sz="1875" b="1">
                 <a:solidFill>
                   <a:srgbClr val="B74736"/>
@@ -2294,6 +2350,7 @@
           <a:lstStyle xmlns:a="http://schemas.openxmlformats.org/drawingml/2006/main"/>
           <a:p xmlns:a="http://schemas.openxmlformats.org/drawingml/2006/main">
             <a:pPr algn="l">
+              <a:buNone/>
               <a:defRPr sz="1875" b="0">
                 <a:solidFill>
                   <a:srgbClr val="202321"/>
@@ -2312,7 +2369,7 @@
                 <a:ea typeface="Microsoft YaHei"/>
                 <a:cs typeface="Microsoft YaHei"/>
               </a:rPr>
-              <a:t>白板批注与选中文字回传</a:t>
+              <a:t>通过白板批注和选中文字提出修改</a:t>
             </a:r>
           </a:p>
         </p:txBody>
@@ -2381,6 +2438,7 @@
           <a:lstStyle xmlns:a="http://schemas.openxmlformats.org/drawingml/2006/main"/>
           <a:p xmlns:a="http://schemas.openxmlformats.org/drawingml/2006/main">
             <a:pPr algn="l">
+              <a:buNone/>
               <a:defRPr sz="1875" b="1">
                 <a:solidFill>
                   <a:srgbClr val="B74736"/>
@@ -2399,7 +2457,7 @@
                 <a:ea typeface="Microsoft YaHei"/>
                 <a:cs typeface="Microsoft YaHei"/>
               </a:rPr>
-              <a:t>执行与恢复</a:t>
+              <a:t>工具调用</a:t>
             </a:r>
           </a:p>
         </p:txBody>
@@ -2438,6 +2496,7 @@
           <a:lstStyle xmlns:a="http://schemas.openxmlformats.org/drawingml/2006/main"/>
           <a:p xmlns:a="http://schemas.openxmlformats.org/drawingml/2006/main">
             <a:pPr algn="l">
+              <a:buNone/>
               <a:defRPr sz="1875" b="0">
                 <a:solidFill>
                   <a:srgbClr val="202321"/>
@@ -2456,7 +2515,7 @@
                 <a:ea typeface="Microsoft YaHei"/>
                 <a:cs typeface="Microsoft YaHei"/>
               </a:rPr>
-              <a:t>统一 CAD 接口、首个 Hub 运行时</a:t>
+              <a:t>统一 CAD 接口，Hub 管理执行过程</a:t>
             </a:r>
           </a:p>
         </p:txBody>
@@ -2525,6 +2584,7 @@
           <a:lstStyle xmlns:a="http://schemas.openxmlformats.org/drawingml/2006/main"/>
           <a:p xmlns:a="http://schemas.openxmlformats.org/drawingml/2006/main">
             <a:pPr algn="l">
+              <a:buNone/>
               <a:defRPr sz="1875" b="1">
                 <a:solidFill>
                   <a:srgbClr val="B74736"/>
@@ -2582,6 +2642,7 @@
           <a:lstStyle xmlns:a="http://schemas.openxmlformats.org/drawingml/2006/main"/>
           <a:p xmlns:a="http://schemas.openxmlformats.org/drawingml/2006/main">
             <a:pPr algn="l">
+              <a:buNone/>
               <a:defRPr sz="1875" b="0">
                 <a:solidFill>
                   <a:srgbClr val="202321"/>
@@ -2600,7 +2661,7 @@
                 <a:ea typeface="Microsoft YaHei"/>
                 <a:cs typeface="Microsoft YaHei"/>
               </a:rPr>
-              <a:t>Windows 薄宿主已合入 main</a:t>
+              <a:t>Windows 桌面入口已合入 main</a:t>
             </a:r>
           </a:p>
         </p:txBody>
@@ -2669,6 +2730,7 @@
           <a:lstStyle xmlns:a="http://schemas.openxmlformats.org/drawingml/2006/main"/>
           <a:p xmlns:a="http://schemas.openxmlformats.org/drawingml/2006/main">
             <a:pPr algn="l">
+              <a:buNone/>
               <a:defRPr sz="1875" b="0">
                 <a:solidFill>
                   <a:srgbClr val="202321"/>
@@ -2687,7 +2749,7 @@
                 <a:ea typeface="Microsoft YaHei"/>
                 <a:cs typeface="Microsoft YaHei"/>
               </a:rPr>
-              <a:t>本次会议确定：每条线的负责人、首个交付物，以及两周后的可用结果</a:t>
+              <a:t>本次会议讨论四组工作的分工，以及两周内能够完成的内容</a:t>
             </a:r>
           </a:p>
         </p:txBody>
@@ -2755,6 +2817,7 @@
           <a:lstStyle xmlns:a="http://schemas.openxmlformats.org/drawingml/2006/main"/>
           <a:p xmlns:a="http://schemas.openxmlformats.org/drawingml/2006/main">
             <a:pPr algn="l">
+              <a:buNone/>
               <a:defRPr sz="3300" b="1">
                 <a:solidFill>
                   <a:srgbClr val="202321"/>
@@ -2773,7 +2836,7 @@
                 <a:ea typeface="Microsoft YaHei"/>
                 <a:cs typeface="Microsoft YaHei"/>
               </a:rPr>
-              <a:t>共享架构</a:t>
+              <a:t>项目状态与工具的关系</a:t>
             </a:r>
           </a:p>
         </p:txBody>
@@ -2812,6 +2875,7 @@
           <a:lstStyle xmlns:a="http://schemas.openxmlformats.org/drawingml/2006/main"/>
           <a:p xmlns:a="http://schemas.openxmlformats.org/drawingml/2006/main">
             <a:pPr algn="l">
+              <a:buNone/>
               <a:defRPr sz="1950" b="0">
                 <a:solidFill>
                   <a:srgbClr val="646B66"/>
@@ -2830,7 +2894,7 @@
                 <a:ea typeface="Microsoft YaHei"/>
                 <a:cs typeface="Microsoft YaHei"/>
               </a:rPr>
-              <a:t>生成方式可以替换，项目状态持续保留</a:t>
+              <a:t>ArchFlow 保存项目及其修改关系，运行时调用工具并返回结果</a:t>
             </a:r>
           </a:p>
         </p:txBody>
@@ -2899,6 +2963,7 @@
           <a:lstStyle xmlns:a="http://schemas.openxmlformats.org/drawingml/2006/main"/>
           <a:p xmlns:a="http://schemas.openxmlformats.org/drawingml/2006/main">
             <a:pPr algn="l">
+              <a:buNone/>
               <a:defRPr sz="1200" b="0">
                 <a:solidFill>
                   <a:srgbClr val="646B66"/>
@@ -2956,6 +3021,7 @@
           <a:lstStyle xmlns:a="http://schemas.openxmlformats.org/drawingml/2006/main"/>
           <a:p xmlns:a="http://schemas.openxmlformats.org/drawingml/2006/main">
             <a:pPr algn="r">
+              <a:buNone/>
               <a:defRPr sz="1350" b="0">
                 <a:solidFill>
                   <a:srgbClr val="646B66"/>
@@ -3045,6 +3111,7 @@
           <a:lstStyle xmlns:a="http://schemas.openxmlformats.org/drawingml/2006/main"/>
           <a:p xmlns:a="http://schemas.openxmlformats.org/drawingml/2006/main">
             <a:pPr algn="ctr">
+              <a:buNone/>
               <a:defRPr sz="1950" b="1">
                 <a:solidFill>
                   <a:srgbClr val="202321"/>
@@ -3102,6 +3169,7 @@
           <a:lstStyle xmlns:a="http://schemas.openxmlformats.org/drawingml/2006/main"/>
           <a:p xmlns:a="http://schemas.openxmlformats.org/drawingml/2006/main">
             <a:pPr algn="ctr">
+              <a:buNone/>
               <a:defRPr sz="1575" b="0">
                 <a:solidFill>
                   <a:srgbClr val="646B66"/>
@@ -3120,7 +3188,7 @@
                 <a:ea typeface="Microsoft YaHei"/>
                 <a:cs typeface="Microsoft YaHei"/>
               </a:rPr>
-              <a:t>提出意图或类型化动作</a:t>
+              <a:t>提出设计意图或修改动作</a:t>
             </a:r>
           </a:p>
         </p:txBody>
@@ -3191,6 +3259,7 @@
           <a:lstStyle xmlns:a="http://schemas.openxmlformats.org/drawingml/2006/main"/>
           <a:p xmlns:a="http://schemas.openxmlformats.org/drawingml/2006/main">
             <a:pPr algn="ctr">
+              <a:buNone/>
               <a:defRPr sz="1950" b="1">
                 <a:solidFill>
                   <a:srgbClr val="B74736"/>
@@ -3248,6 +3317,7 @@
           <a:lstStyle xmlns:a="http://schemas.openxmlformats.org/drawingml/2006/main"/>
           <a:p xmlns:a="http://schemas.openxmlformats.org/drawingml/2006/main">
             <a:pPr algn="ctr">
+              <a:buNone/>
               <a:defRPr sz="1575" b="0">
                 <a:solidFill>
                   <a:srgbClr val="646B66"/>
@@ -3266,7 +3336,7 @@
                 <a:ea typeface="Microsoft YaHei"/>
                 <a:cs typeface="Microsoft YaHei"/>
               </a:rPr>
-              <a:t>身份 · 依赖 · 来源 · 版本</a:t>
+              <a:t>对象身份、依赖、来源与版本</a:t>
             </a:r>
           </a:p>
         </p:txBody>
@@ -3337,6 +3407,7 @@
           <a:lstStyle xmlns:a="http://schemas.openxmlformats.org/drawingml/2006/main"/>
           <a:p xmlns:a="http://schemas.openxmlformats.org/drawingml/2006/main">
             <a:pPr algn="ctr">
+              <a:buNone/>
               <a:defRPr sz="1950" b="1">
                 <a:solidFill>
                   <a:srgbClr val="202321"/>
@@ -3394,6 +3465,7 @@
           <a:lstStyle xmlns:a="http://schemas.openxmlformats.org/drawingml/2006/main"/>
           <a:p xmlns:a="http://schemas.openxmlformats.org/drawingml/2006/main">
             <a:pPr algn="ctr">
+              <a:buNone/>
               <a:defRPr sz="1575" b="0">
                 <a:solidFill>
                   <a:srgbClr val="646B66"/>
@@ -3412,14 +3484,14 @@
                 <a:ea typeface="Microsoft YaHei"/>
                 <a:cs typeface="Microsoft YaHei"/>
               </a:rPr>
-              <a:t>操作 · 工作进程 · 恢复 · 投影</a:t>
+              <a:t>调度操作、恢复任务、更新模型</a:t>
             </a:r>
           </a:p>
         </p:txBody>
       </p:sp>
       <p:cxnSp>
         <p:nvCxnSpPr>
-          <p:cNvPr id="39" name=""/>
+          <p:cNvPr id="59" name=""/>
           <p:cNvCxnSpPr>
             <a:stCxn xmlns:a="http://schemas.openxmlformats.org/drawingml/2006/main" id="6" idx="3"/>
             <a:endCxn xmlns:a="http://schemas.openxmlformats.org/drawingml/2006/main" id="9" idx="1"/>
@@ -3444,7 +3516,7 @@
       </p:cxnSp>
       <p:cxnSp>
         <p:nvCxnSpPr>
-          <p:cNvPr id="40" name=""/>
+          <p:cNvPr id="60" name=""/>
           <p:cNvCxnSpPr>
             <a:stCxn xmlns:a="http://schemas.openxmlformats.org/drawingml/2006/main" id="9" idx="3"/>
             <a:endCxn xmlns:a="http://schemas.openxmlformats.org/drawingml/2006/main" id="12" idx="1"/>
@@ -3533,6 +3605,7 @@
           <a:lstStyle xmlns:a="http://schemas.openxmlformats.org/drawingml/2006/main"/>
           <a:p xmlns:a="http://schemas.openxmlformats.org/drawingml/2006/main">
             <a:pPr algn="ctr">
+              <a:buNone/>
               <a:defRPr sz="1950" b="1">
                 <a:solidFill>
                   <a:srgbClr val="202321"/>
@@ -3590,6 +3663,7 @@
           <a:lstStyle xmlns:a="http://schemas.openxmlformats.org/drawingml/2006/main"/>
           <a:p xmlns:a="http://schemas.openxmlformats.org/drawingml/2006/main">
             <a:pPr algn="ctr">
+              <a:buNone/>
               <a:defRPr sz="1575" b="0">
                 <a:solidFill>
                   <a:srgbClr val="646B66"/>
@@ -3615,7 +3689,7 @@
       </p:sp>
       <p:cxnSp>
         <p:nvCxnSpPr>
-          <p:cNvPr id="44" name=""/>
+          <p:cNvPr id="64" name=""/>
           <p:cNvCxnSpPr>
             <a:stCxn xmlns:a="http://schemas.openxmlformats.org/drawingml/2006/main" id="12" idx="2"/>
             <a:endCxn xmlns:a="http://schemas.openxmlformats.org/drawingml/2006/main" id="17" idx="0"/>
@@ -3675,6 +3749,7 @@
           <a:lstStyle xmlns:a="http://schemas.openxmlformats.org/drawingml/2006/main"/>
           <a:p xmlns:a="http://schemas.openxmlformats.org/drawingml/2006/main">
             <a:pPr algn="l">
+              <a:buNone/>
               <a:defRPr sz="1800" b="0">
                 <a:solidFill>
                   <a:srgbClr val="646B66"/>
@@ -3693,7 +3768,7 @@
                 <a:ea typeface="Microsoft YaHei"/>
                 <a:cs typeface="Microsoft YaHei"/>
               </a:rPr>
-              <a:t>类型化动作</a:t>
+              <a:t>修改以明确的动作传递</a:t>
             </a:r>
           </a:p>
         </p:txBody>
@@ -3732,6 +3807,7 @@
           <a:lstStyle xmlns:a="http://schemas.openxmlformats.org/drawingml/2006/main"/>
           <a:p xmlns:a="http://schemas.openxmlformats.org/drawingml/2006/main">
             <a:pPr algn="l">
+              <a:buNone/>
               <a:defRPr sz="2025" b="0">
                 <a:solidFill>
                   <a:srgbClr val="202321"/>
@@ -3750,11 +3826,12 @@
                 <a:ea typeface="Microsoft YaHei"/>
                 <a:cs typeface="Microsoft YaHei"/>
               </a:rPr>
-              <a:t>项目版本持续保留</a:t>
+              <a:t>项目记录修改过程</a:t>
             </a:r>
           </a:p>
           <a:p xmlns:a="http://schemas.openxmlformats.org/drawingml/2006/main">
             <a:pPr algn="l">
+              <a:buNone/>
               <a:defRPr sz="2025" b="0">
                 <a:solidFill>
                   <a:srgbClr val="202321"/>
@@ -3773,7 +3850,7 @@
                 <a:ea typeface="Microsoft YaHei"/>
                 <a:cs typeface="Microsoft YaHei"/>
               </a:rPr>
-              <a:t>候选可读回、可继续修改</a:t>
+              <a:t>候选可继续编辑</a:t>
             </a:r>
           </a:p>
         </p:txBody>
@@ -3842,6 +3919,7 @@
           <a:lstStyle xmlns:a="http://schemas.openxmlformats.org/drawingml/2006/main"/>
           <a:p xmlns:a="http://schemas.openxmlformats.org/drawingml/2006/main">
             <a:pPr algn="l">
+              <a:buNone/>
               <a:defRPr sz="1875" b="0">
                 <a:solidFill>
                   <a:srgbClr val="202321"/>
@@ -3860,7 +3938,7 @@
                 <a:ea typeface="Microsoft YaHei"/>
                 <a:cs typeface="Microsoft YaHei"/>
               </a:rPr>
-              <a:t>产品界面围绕同一项目工作；具体工具通过既有契约执行与呈现</a:t>
+              <a:t>建模、图纸与白板围绕同一项目展开，各工具负责相应的计算和呈现</a:t>
             </a:r>
           </a:p>
         </p:txBody>
@@ -3928,6 +4006,7 @@
           <a:lstStyle xmlns:a="http://schemas.openxmlformats.org/drawingml/2006/main"/>
           <a:p xmlns:a="http://schemas.openxmlformats.org/drawingml/2006/main">
             <a:pPr algn="l">
+              <a:buNone/>
               <a:defRPr sz="3300" b="1">
                 <a:solidFill>
                   <a:srgbClr val="202321"/>
@@ -3946,7 +4025,7 @@
                 <a:ea typeface="Microsoft YaHei"/>
                 <a:cs typeface="Microsoft YaHei"/>
               </a:rPr>
-              <a:t>四条工作线</a:t>
+              <a:t>两周工作安排</a:t>
             </a:r>
           </a:p>
         </p:txBody>
@@ -3985,6 +4064,7 @@
           <a:lstStyle xmlns:a="http://schemas.openxmlformats.org/drawingml/2006/main"/>
           <a:p xmlns:a="http://schemas.openxmlformats.org/drawingml/2006/main">
             <a:pPr algn="l">
+              <a:buNone/>
               <a:defRPr sz="1950" b="0">
                 <a:solidFill>
                   <a:srgbClr val="646B66"/>
@@ -4003,7 +4083,7 @@
                 <a:ea typeface="Microsoft YaHei"/>
                 <a:cs typeface="Microsoft YaHei"/>
               </a:rPr>
-              <a:t>每条线承担一个清楚的交付，并约定与其他线的接口</a:t>
+              <a:t>四组分别推进研究比较、场景渲染、直接操作和执行效率</a:t>
             </a:r>
           </a:p>
         </p:txBody>
@@ -4072,6 +4152,7 @@
           <a:lstStyle xmlns:a="http://schemas.openxmlformats.org/drawingml/2006/main"/>
           <a:p xmlns:a="http://schemas.openxmlformats.org/drawingml/2006/main">
             <a:pPr algn="l">
+              <a:buNone/>
               <a:defRPr sz="1200" b="0">
                 <a:solidFill>
                   <a:srgbClr val="646B66"/>
@@ -4129,6 +4210,7 @@
           <a:lstStyle xmlns:a="http://schemas.openxmlformats.org/drawingml/2006/main"/>
           <a:p xmlns:a="http://schemas.openxmlformats.org/drawingml/2006/main">
             <a:pPr algn="r">
+              <a:buNone/>
               <a:defRPr sz="1350" b="0">
                 <a:solidFill>
                   <a:srgbClr val="646B66"/>
@@ -4154,7 +4236,7 @@
       </p:sp>
       <p:graphicFrame>
         <p:nvGraphicFramePr>
-          <p:cNvPr id="14" name=""/>
+          <p:cNvPr id="16" name=""/>
           <p:cNvGraphicFramePr/>
           <p:nvPr/>
         </p:nvGraphicFramePr>
@@ -4189,7 +4271,7 @@
                           <a:ea typeface="Microsoft YaHei"/>
                           <a:cs typeface="Microsoft YaHei"/>
                         </a:rPr>
-                        <a:t>工作线</a:t>
+                        <a:t>方向</a:t>
                       </a:r>
                     </a:p>
                   </a:txBody>
@@ -4215,7 +4297,7 @@
                           <a:ea typeface="Microsoft YaHei"/>
                           <a:cs typeface="Microsoft YaHei"/>
                         </a:rPr>
-                        <a:t>首个交付</a:t>
+                        <a:t>近期工作</a:t>
                       </a:r>
                     </a:p>
                   </a:txBody>
@@ -4241,7 +4323,7 @@
                           <a:ea typeface="Microsoft YaHei"/>
                           <a:cs typeface="Microsoft YaHei"/>
                         </a:rPr>
-                        <a:t>两周可用结果</a:t>
+                        <a:t>两周成果</a:t>
                       </a:r>
                     </a:p>
                   </a:txBody>
@@ -4267,7 +4349,7 @@
                           <a:ea typeface="Microsoft YaHei"/>
                           <a:cs typeface="Microsoft YaHei"/>
                         </a:rPr>
-                        <a:t>协作边界</a:t>
+                        <a:t>负责范围</a:t>
                       </a:r>
                     </a:p>
                   </a:txBody>
@@ -4321,7 +4403,7 @@
                           <a:ea typeface="Microsoft YaHei"/>
                           <a:cs typeface="Microsoft YaHei"/>
                         </a:rPr>
-                        <a:t>术语图与基准协议</a:t>
+                        <a:t>术语与实验方案</a:t>
                       </a:r>
                     </a:p>
                   </a:txBody>
@@ -4347,7 +4429,7 @@
                           <a:ea typeface="Microsoft YaHei"/>
                           <a:cs typeface="Microsoft YaHei"/>
                         </a:rPr>
-                        <a:t>研究图、结果表与可检验主张</a:t>
+                        <a:t>架构图、比较结果及研究判断</a:t>
                       </a:r>
                     </a:p>
                   </a:txBody>
@@ -4373,7 +4455,7 @@
                           <a:ea typeface="Microsoft YaHei"/>
                           <a:cs typeface="Microsoft YaHei"/>
                         </a:rPr>
-                        <a:t>测量与形式化</a:t>
+                        <a:t>实验设计与分析</a:t>
                       </a:r>
                     </a:p>
                   </a:txBody>
@@ -4427,7 +4509,7 @@
                           <a:ea typeface="Microsoft YaHei"/>
                           <a:cs typeface="Microsoft YaHei"/>
                         </a:rPr>
-                        <a:t>原生 .blend 投影</a:t>
+                        <a:t>原生 .blend 场景</a:t>
                       </a:r>
                     </a:p>
                   </a:txBody>
@@ -4453,7 +4535,7 @@
                           <a:ea typeface="Microsoft YaHei"/>
                           <a:cs typeface="Microsoft YaHei"/>
                         </a:rPr>
-                        <a:t>修改前后各渲染一张 PNG</a:t>
+                        <a:t>修改前后的场景与渲染图</a:t>
                       </a:r>
                     </a:p>
                   </a:txBody>
@@ -4479,7 +4561,7 @@
                           <a:ea typeface="Microsoft YaHei"/>
                           <a:cs typeface="Microsoft YaHei"/>
                         </a:rPr>
-                        <a:t>执行 / 场景投影</a:t>
+                        <a:t>场景生成与更新</a:t>
                       </a:r>
                     </a:p>
                   </a:txBody>
@@ -4533,7 +4615,7 @@
                           <a:ea typeface="Microsoft YaHei"/>
                           <a:cs typeface="Microsoft YaHei"/>
                         </a:rPr>
-                        <a:t>Move / Copy 指针操作</a:t>
+                        <a:t>指针操作与吸附</a:t>
                       </a:r>
                     </a:p>
                   </a:txBody>
@@ -4559,7 +4641,7 @@
                           <a:ea typeface="Microsoft YaHei"/>
                           <a:cs typeface="Microsoft YaHei"/>
                         </a:rPr>
-                        <a:t>连续建模数分钟的直接体验</a:t>
+                        <a:t>连续编辑简单体量模型</a:t>
                       </a:r>
                     </a:p>
                   </a:txBody>
@@ -4585,7 +4667,7 @@
                           <a:ea typeface="Microsoft YaHei"/>
                           <a:cs typeface="Microsoft YaHei"/>
                         </a:rPr>
-                        <a:t>本地草稿 / 类型化动作</a:t>
+                        <a:t>本地编辑与草稿</a:t>
                       </a:r>
                     </a:p>
                   </a:txBody>
@@ -4639,7 +4721,7 @@
                           <a:ea typeface="Microsoft YaHei"/>
                           <a:cs typeface="Microsoft YaHei"/>
                         </a:rPr>
-                        <a:t>TurnTrace + Monitor</a:t>
+                        <a:t>任务记录与 Monitor</a:t>
                       </a:r>
                     </a:p>
                   </a:txBody>
@@ -4665,7 +4747,7 @@
                           <a:ea typeface="Microsoft YaHei"/>
                           <a:cs typeface="Microsoft YaHei"/>
                         </a:rPr>
-                        <a:t>解释耗时、减少模型轮次</a:t>
+                        <a:t>各环节耗时与调用次数比较</a:t>
                       </a:r>
                     </a:p>
                   </a:txBody>
@@ -4691,7 +4773,7 @@
                           <a:ea typeface="Microsoft YaHei"/>
                           <a:cs typeface="Microsoft YaHei"/>
                         </a:rPr>
-                        <a:t>上下文 / 执行 / 恢复</a:t>
+                        <a:t>任务上下文与执行</a:t>
                       </a:r>
                     </a:p>
                   </a:txBody>
@@ -4770,6 +4852,7 @@
           <a:lstStyle xmlns:a="http://schemas.openxmlformats.org/drawingml/2006/main"/>
           <a:p xmlns:a="http://schemas.openxmlformats.org/drawingml/2006/main">
             <a:pPr algn="l">
+              <a:buNone/>
               <a:defRPr sz="1875" b="0">
                 <a:solidFill>
                   <a:srgbClr val="202321"/>
@@ -4788,7 +4871,7 @@
                 <a:ea typeface="Microsoft YaHei"/>
                 <a:cs typeface="Microsoft YaHei"/>
               </a:rPr>
-              <a:t>接口需要共同修改时，先合入一个小的契约 PR，再分别推进实现</a:t>
+              <a:t>涉及多组共用的接口时，先完成接口修改，再开展各组的实现</a:t>
             </a:r>
           </a:p>
         </p:txBody>
@@ -4856,6 +4939,7 @@
           <a:lstStyle xmlns:a="http://schemas.openxmlformats.org/drawingml/2006/main"/>
           <a:p xmlns:a="http://schemas.openxmlformats.org/drawingml/2006/main">
             <a:pPr algn="l">
+              <a:buNone/>
               <a:defRPr sz="3300" b="1">
                 <a:solidFill>
                   <a:srgbClr val="202321"/>
@@ -4874,7 +4958,7 @@
                 <a:ea typeface="Microsoft YaHei"/>
                 <a:cs typeface="Microsoft YaHei"/>
               </a:rPr>
-              <a:t>Paper · 研究问题与三路比较</a:t>
+              <a:t>Paper / 研究问题与比较方法</a:t>
             </a:r>
           </a:p>
         </p:txBody>
@@ -4913,6 +4997,7 @@
           <a:lstStyle xmlns:a="http://schemas.openxmlformats.org/drawingml/2006/main"/>
           <a:p xmlns:a="http://schemas.openxmlformats.org/drawingml/2006/main">
             <a:pPr algn="l">
+              <a:buNone/>
               <a:defRPr sz="1950" b="0">
                 <a:solidFill>
                   <a:srgbClr val="646B66"/>
@@ -4931,7 +5016,7 @@
                 <a:ea typeface="Microsoft YaHei"/>
                 <a:cs typeface="Microsoft YaHei"/>
               </a:rPr>
-              <a:t>通用 Agent 能否把设计意图交给确定性运行时执行？</a:t>
+              <a:t>通用 Agent 能否将设计意图编译为事务，由运行时完成 CAD 操作？</a:t>
             </a:r>
           </a:p>
         </p:txBody>
@@ -5000,6 +5085,7 @@
           <a:lstStyle xmlns:a="http://schemas.openxmlformats.org/drawingml/2006/main"/>
           <a:p xmlns:a="http://schemas.openxmlformats.org/drawingml/2006/main">
             <a:pPr algn="l">
+              <a:buNone/>
               <a:defRPr sz="1200" b="0">
                 <a:solidFill>
                   <a:srgbClr val="646B66"/>
@@ -5057,6 +5143,7 @@
           <a:lstStyle xmlns:a="http://schemas.openxmlformats.org/drawingml/2006/main"/>
           <a:p xmlns:a="http://schemas.openxmlformats.org/drawingml/2006/main">
             <a:pPr algn="r">
+              <a:buNone/>
               <a:defRPr sz="1350" b="0">
                 <a:solidFill>
                   <a:srgbClr val="646B66"/>
@@ -5114,6 +5201,7 @@
           <a:lstStyle xmlns:a="http://schemas.openxmlformats.org/drawingml/2006/main"/>
           <a:p xmlns:a="http://schemas.openxmlformats.org/drawingml/2006/main">
             <a:pPr algn="l">
+              <a:buNone/>
               <a:defRPr sz="2625" b="1">
                 <a:solidFill>
                   <a:srgbClr val="202321"/>
@@ -5171,6 +5259,7 @@
           <a:lstStyle xmlns:a="http://schemas.openxmlformats.org/drawingml/2006/main"/>
           <a:p xmlns:a="http://schemas.openxmlformats.org/drawingml/2006/main">
             <a:pPr algn="l">
+              <a:buNone/>
               <a:defRPr sz="1950" b="0">
                 <a:solidFill>
                   <a:srgbClr val="202321"/>
@@ -5189,7 +5278,7 @@
                 <a:ea typeface="Microsoft YaHei"/>
                 <a:cs typeface="Microsoft YaHei"/>
               </a:rPr>
-              <a:t>直接 CAD Agent</a:t>
+              <a:t>直接操作 CAD</a:t>
             </a:r>
           </a:p>
         </p:txBody>
@@ -5260,6 +5349,7 @@
           <a:lstStyle xmlns:a="http://schemas.openxmlformats.org/drawingml/2006/main"/>
           <a:p xmlns:a="http://schemas.openxmlformats.org/drawingml/2006/main">
             <a:pPr algn="ctr">
+              <a:buNone/>
               <a:defRPr sz="1950" b="1">
                 <a:solidFill>
                   <a:srgbClr val="202321"/>
@@ -5278,7 +5368,7 @@
                 <a:ea typeface="Microsoft YaHei"/>
                 <a:cs typeface="Microsoft YaHei"/>
               </a:rPr>
-              <a:t>发现对象</a:t>
+              <a:t>读取 CAD 对象</a:t>
             </a:r>
           </a:p>
         </p:txBody>
@@ -5349,6 +5439,7 @@
           <a:lstStyle xmlns:a="http://schemas.openxmlformats.org/drawingml/2006/main"/>
           <a:p xmlns:a="http://schemas.openxmlformats.org/drawingml/2006/main">
             <a:pPr algn="ctr">
+              <a:buNone/>
               <a:defRPr sz="1950" b="1">
                 <a:solidFill>
                   <a:srgbClr val="202321"/>
@@ -5374,7 +5465,7 @@
       </p:sp>
       <p:cxnSp>
         <p:nvCxnSpPr>
-          <p:cNvPr id="50" name=""/>
+          <p:cNvPr id="85" name=""/>
           <p:cNvCxnSpPr>
             <a:stCxn xmlns:a="http://schemas.openxmlformats.org/drawingml/2006/main" id="8" idx="3"/>
             <a:endCxn xmlns:a="http://schemas.openxmlformats.org/drawingml/2006/main" id="10" idx="1"/>
@@ -5463,6 +5554,7 @@
           <a:lstStyle xmlns:a="http://schemas.openxmlformats.org/drawingml/2006/main"/>
           <a:p xmlns:a="http://schemas.openxmlformats.org/drawingml/2006/main">
             <a:pPr algn="ctr">
+              <a:buNone/>
               <a:defRPr sz="1950" b="1">
                 <a:solidFill>
                   <a:srgbClr val="202321"/>
@@ -5488,7 +5580,7 @@
       </p:sp>
       <p:cxnSp>
         <p:nvCxnSpPr>
-          <p:cNvPr id="53" name=""/>
+          <p:cNvPr id="88" name=""/>
           <p:cNvCxnSpPr>
             <a:stCxn xmlns:a="http://schemas.openxmlformats.org/drawingml/2006/main" id="10" idx="3"/>
             <a:endCxn xmlns:a="http://schemas.openxmlformats.org/drawingml/2006/main" id="13" idx="1"/>
@@ -5545,6 +5637,7 @@
           <a:lstStyle xmlns:a="http://schemas.openxmlformats.org/drawingml/2006/main"/>
           <a:p xmlns:a="http://schemas.openxmlformats.org/drawingml/2006/main">
             <a:pPr algn="l">
+              <a:buNone/>
               <a:defRPr sz="2625" b="1">
                 <a:solidFill>
                   <a:srgbClr val="202321"/>
@@ -5602,6 +5695,7 @@
           <a:lstStyle xmlns:a="http://schemas.openxmlformats.org/drawingml/2006/main"/>
           <a:p xmlns:a="http://schemas.openxmlformats.org/drawingml/2006/main">
             <a:pPr algn="l">
+              <a:buNone/>
               <a:defRPr sz="1950" b="0">
                 <a:solidFill>
                   <a:srgbClr val="202321"/>
@@ -5691,6 +5785,7 @@
           <a:lstStyle xmlns:a="http://schemas.openxmlformats.org/drawingml/2006/main"/>
           <a:p xmlns:a="http://schemas.openxmlformats.org/drawingml/2006/main">
             <a:pPr algn="ctr">
+              <a:buNone/>
               <a:defRPr sz="1950" b="1">
                 <a:solidFill>
                   <a:srgbClr val="202321"/>
@@ -5780,6 +5875,7 @@
           <a:lstStyle xmlns:a="http://schemas.openxmlformats.org/drawingml/2006/main"/>
           <a:p xmlns:a="http://schemas.openxmlformats.org/drawingml/2006/main">
             <a:pPr algn="ctr">
+              <a:buNone/>
               <a:defRPr sz="1950" b="1">
                 <a:solidFill>
                   <a:srgbClr val="202321"/>
@@ -5798,14 +5894,14 @@
                 <a:ea typeface="Microsoft YaHei"/>
                 <a:cs typeface="Microsoft YaHei"/>
               </a:rPr>
-              <a:t>多轮模型 / 工具</a:t>
+              <a:t>多轮调用工具</a:t>
             </a:r>
           </a:p>
         </p:txBody>
       </p:sp>
       <p:cxnSp>
         <p:nvCxnSpPr>
-          <p:cNvPr id="60" name=""/>
+          <p:cNvPr id="95" name=""/>
           <p:cNvCxnSpPr>
             <a:stCxn xmlns:a="http://schemas.openxmlformats.org/drawingml/2006/main" id="18" idx="3"/>
             <a:endCxn xmlns:a="http://schemas.openxmlformats.org/drawingml/2006/main" id="20" idx="1"/>
@@ -5894,6 +5990,7 @@
           <a:lstStyle xmlns:a="http://schemas.openxmlformats.org/drawingml/2006/main"/>
           <a:p xmlns:a="http://schemas.openxmlformats.org/drawingml/2006/main">
             <a:pPr algn="ctr">
+              <a:buNone/>
               <a:defRPr sz="1950" b="1">
                 <a:solidFill>
                   <a:srgbClr val="202321"/>
@@ -5919,7 +6016,7 @@
       </p:sp>
       <p:cxnSp>
         <p:nvCxnSpPr>
-          <p:cNvPr id="63" name=""/>
+          <p:cNvPr id="98" name=""/>
           <p:cNvCxnSpPr>
             <a:stCxn xmlns:a="http://schemas.openxmlformats.org/drawingml/2006/main" id="20" idx="3"/>
             <a:endCxn xmlns:a="http://schemas.openxmlformats.org/drawingml/2006/main" id="23" idx="1"/>
@@ -5976,6 +6073,7 @@
           <a:lstStyle xmlns:a="http://schemas.openxmlformats.org/drawingml/2006/main"/>
           <a:p xmlns:a="http://schemas.openxmlformats.org/drawingml/2006/main">
             <a:pPr algn="l">
+              <a:buNone/>
               <a:defRPr sz="2625" b="1">
                 <a:solidFill>
                   <a:srgbClr val="B74736"/>
@@ -6033,6 +6131,7 @@
           <a:lstStyle xmlns:a="http://schemas.openxmlformats.org/drawingml/2006/main"/>
           <a:p xmlns:a="http://schemas.openxmlformats.org/drawingml/2006/main">
             <a:pPr algn="l">
+              <a:buNone/>
               <a:defRPr sz="1950" b="0">
                 <a:solidFill>
                   <a:srgbClr val="202321"/>
@@ -6051,7 +6150,7 @@
                 <a:ea typeface="Microsoft YaHei"/>
                 <a:cs typeface="Microsoft YaHei"/>
               </a:rPr>
-              <a:t>拟验证路径</a:t>
+              <a:t>拟研究方案</a:t>
             </a:r>
           </a:p>
         </p:txBody>
@@ -6122,6 +6221,7 @@
           <a:lstStyle xmlns:a="http://schemas.openxmlformats.org/drawingml/2006/main"/>
           <a:p xmlns:a="http://schemas.openxmlformats.org/drawingml/2006/main">
             <a:pPr algn="ctr">
+              <a:buNone/>
               <a:defRPr sz="1950" b="1">
                 <a:solidFill>
                   <a:srgbClr val="B74736"/>
@@ -6140,7 +6240,7 @@
                 <a:ea typeface="Microsoft YaHei"/>
                 <a:cs typeface="Microsoft YaHei"/>
               </a:rPr>
-              <a:t>编译上下文</a:t>
+              <a:t>整理任务上下文</a:t>
             </a:r>
           </a:p>
         </p:txBody>
@@ -6211,6 +6311,7 @@
           <a:lstStyle xmlns:a="http://schemas.openxmlformats.org/drawingml/2006/main"/>
           <a:p xmlns:a="http://schemas.openxmlformats.org/drawingml/2006/main">
             <a:pPr algn="ctr">
+              <a:buNone/>
               <a:defRPr sz="1950" b="1">
                 <a:solidFill>
                   <a:srgbClr val="B74736"/>
@@ -6229,14 +6330,14 @@
                 <a:ea typeface="Microsoft YaHei"/>
                 <a:cs typeface="Microsoft YaHei"/>
               </a:rPr>
-              <a:t>决策 → 事务</a:t>
+              <a:t>生成设计事务</a:t>
             </a:r>
           </a:p>
         </p:txBody>
       </p:sp>
       <p:cxnSp>
         <p:nvCxnSpPr>
-          <p:cNvPr id="70" name=""/>
+          <p:cNvPr id="105" name=""/>
           <p:cNvCxnSpPr>
             <a:stCxn xmlns:a="http://schemas.openxmlformats.org/drawingml/2006/main" id="28" idx="3"/>
             <a:endCxn xmlns:a="http://schemas.openxmlformats.org/drawingml/2006/main" id="30" idx="1"/>
@@ -6325,6 +6426,7 @@
           <a:lstStyle xmlns:a="http://schemas.openxmlformats.org/drawingml/2006/main"/>
           <a:p xmlns:a="http://schemas.openxmlformats.org/drawingml/2006/main">
             <a:pPr algn="ctr">
+              <a:buNone/>
               <a:defRPr sz="1950" b="1">
                 <a:solidFill>
                   <a:srgbClr val="B74736"/>
@@ -6343,14 +6445,14 @@
                 <a:ea typeface="Microsoft YaHei"/>
                 <a:cs typeface="Microsoft YaHei"/>
               </a:rPr>
-              <a:t>运行时 → 候选</a:t>
+              <a:t>执行并生成候选</a:t>
             </a:r>
           </a:p>
         </p:txBody>
       </p:sp>
       <p:cxnSp>
         <p:nvCxnSpPr>
-          <p:cNvPr id="73" name=""/>
+          <p:cNvPr id="108" name=""/>
           <p:cNvCxnSpPr>
             <a:stCxn xmlns:a="http://schemas.openxmlformats.org/drawingml/2006/main" id="30" idx="3"/>
             <a:endCxn xmlns:a="http://schemas.openxmlformats.org/drawingml/2006/main" id="33" idx="1"/>
@@ -6407,6 +6509,7 @@
           <a:lstStyle xmlns:a="http://schemas.openxmlformats.org/drawingml/2006/main"/>
           <a:p xmlns:a="http://schemas.openxmlformats.org/drawingml/2006/main">
             <a:pPr algn="l">
+              <a:buNone/>
               <a:defRPr sz="1800" b="0">
                 <a:solidFill>
                   <a:srgbClr val="646B66"/>
@@ -6425,7 +6528,7 @@
                 <a:ea typeface="Microsoft YaHei"/>
                 <a:cs typeface="Microsoft YaHei"/>
               </a:rPr>
-              <a:t>同一任务与起始版本 · 相同模型配置 · 重复采样</a:t>
+              <a:t>固定任务、起始版本和模型配置，重复运行三种方案</a:t>
             </a:r>
           </a:p>
         </p:txBody>
@@ -6494,6 +6597,7 @@
           <a:lstStyle xmlns:a="http://schemas.openxmlformats.org/drawingml/2006/main"/>
           <a:p xmlns:a="http://schemas.openxmlformats.org/drawingml/2006/main">
             <a:pPr algn="l">
+              <a:buNone/>
               <a:defRPr sz="1875" b="0">
                 <a:solidFill>
                   <a:srgbClr val="202321"/>
@@ -6512,7 +6616,7 @@
                 <a:ea typeface="Microsoft YaHei"/>
                 <a:cs typeface="Microsoft YaHei"/>
               </a:rPr>
-              <a:t>两周交付：研究架构图 + 基准协议 + 首张结果表 + 可检验的主张</a:t>
+              <a:t>两周内完成研究架构图与比较实验，用首轮结果讨论研究判断</a:t>
             </a:r>
           </a:p>
         </p:txBody>
@@ -6580,6 +6684,7 @@
           <a:lstStyle xmlns:a="http://schemas.openxmlformats.org/drawingml/2006/main"/>
           <a:p xmlns:a="http://schemas.openxmlformats.org/drawingml/2006/main">
             <a:pPr algn="l">
+              <a:buNone/>
               <a:defRPr sz="3300" b="1">
                 <a:solidFill>
                   <a:srgbClr val="202321"/>
@@ -6598,7 +6703,7 @@
                 <a:ea typeface="Microsoft YaHei"/>
                 <a:cs typeface="Microsoft YaHei"/>
               </a:rPr>
-              <a:t>Blender · 可渲染的场景投影</a:t>
+              <a:t>Blender / 模型的渲染与更新</a:t>
             </a:r>
           </a:p>
         </p:txBody>
@@ -6637,6 +6742,7 @@
           <a:lstStyle xmlns:a="http://schemas.openxmlformats.org/drawingml/2006/main"/>
           <a:p xmlns:a="http://schemas.openxmlformats.org/drawingml/2006/main">
             <a:pPr algn="l">
+              <a:buNone/>
               <a:defRPr sz="1950" b="0">
                 <a:solidFill>
                   <a:srgbClr val="646B66"/>
@@ -6655,7 +6761,7 @@
                 <a:ea typeface="Microsoft YaHei"/>
                 <a:cs typeface="Microsoft YaHei"/>
               </a:rPr>
-              <a:t>同一个 ArchFlow 项目，输出并持续更新原生 .blend 场景</a:t>
+              <a:t>从 ArchFlow 项目生成原生 .blend 场景，并在设计修改后更新渲染</a:t>
             </a:r>
           </a:p>
         </p:txBody>
@@ -6724,6 +6830,7 @@
           <a:lstStyle xmlns:a="http://schemas.openxmlformats.org/drawingml/2006/main"/>
           <a:p xmlns:a="http://schemas.openxmlformats.org/drawingml/2006/main">
             <a:pPr algn="l">
+              <a:buNone/>
               <a:defRPr sz="1200" b="0">
                 <a:solidFill>
                   <a:srgbClr val="646B66"/>
@@ -6781,6 +6888,7 @@
           <a:lstStyle xmlns:a="http://schemas.openxmlformats.org/drawingml/2006/main"/>
           <a:p xmlns:a="http://schemas.openxmlformats.org/drawingml/2006/main">
             <a:pPr algn="r">
+              <a:buNone/>
               <a:defRPr sz="1350" b="0">
                 <a:solidFill>
                   <a:srgbClr val="646B66"/>
@@ -6870,6 +6978,7 @@
           <a:lstStyle xmlns:a="http://schemas.openxmlformats.org/drawingml/2006/main"/>
           <a:p xmlns:a="http://schemas.openxmlformats.org/drawingml/2006/main">
             <a:pPr algn="ctr">
+              <a:buNone/>
               <a:defRPr sz="1950" b="1">
                 <a:solidFill>
                   <a:srgbClr val="202321"/>
@@ -6927,6 +7036,7 @@
           <a:lstStyle xmlns:a="http://schemas.openxmlformats.org/drawingml/2006/main"/>
           <a:p xmlns:a="http://schemas.openxmlformats.org/drawingml/2006/main">
             <a:pPr algn="ctr">
+              <a:buNone/>
               <a:defRPr sz="1575" b="0">
                 <a:solidFill>
                   <a:srgbClr val="646B66"/>
@@ -7016,6 +7126,7 @@
           <a:lstStyle xmlns:a="http://schemas.openxmlformats.org/drawingml/2006/main"/>
           <a:p xmlns:a="http://schemas.openxmlformats.org/drawingml/2006/main">
             <a:pPr algn="ctr">
+              <a:buNone/>
               <a:defRPr sz="1950" b="1">
                 <a:solidFill>
                   <a:srgbClr val="202321"/>
@@ -7073,6 +7184,7 @@
           <a:lstStyle xmlns:a="http://schemas.openxmlformats.org/drawingml/2006/main"/>
           <a:p xmlns:a="http://schemas.openxmlformats.org/drawingml/2006/main">
             <a:pPr algn="ctr">
+              <a:buNone/>
               <a:defRPr sz="1575" b="0">
                 <a:solidFill>
                   <a:srgbClr val="646B66"/>
@@ -7162,6 +7274,7 @@
           <a:lstStyle xmlns:a="http://schemas.openxmlformats.org/drawingml/2006/main"/>
           <a:p xmlns:a="http://schemas.openxmlformats.org/drawingml/2006/main">
             <a:pPr algn="ctr">
+              <a:buNone/>
               <a:defRPr sz="1950" b="1">
                 <a:solidFill>
                   <a:srgbClr val="202321"/>
@@ -7180,7 +7293,7 @@
                 <a:ea typeface="Microsoft YaHei"/>
                 <a:cs typeface="Microsoft YaHei"/>
               </a:rPr>
-              <a:t>.blend 投影</a:t>
+              <a:t>.blend 场景</a:t>
             </a:r>
           </a:p>
         </p:txBody>
@@ -7219,6 +7332,7 @@
           <a:lstStyle xmlns:a="http://schemas.openxmlformats.org/drawingml/2006/main"/>
           <a:p xmlns:a="http://schemas.openxmlformats.org/drawingml/2006/main">
             <a:pPr algn="ctr">
+              <a:buNone/>
               <a:defRPr sz="1575" b="0">
                 <a:solidFill>
                   <a:srgbClr val="646B66"/>
@@ -7237,7 +7351,7 @@
                 <a:ea typeface="Microsoft YaHei"/>
                 <a:cs typeface="Microsoft YaHei"/>
               </a:rPr>
-              <a:t>语义集合 / 材料</a:t>
+              <a:t>对象分组与材料</a:t>
             </a:r>
           </a:p>
         </p:txBody>
@@ -7308,6 +7422,7 @@
           <a:lstStyle xmlns:a="http://schemas.openxmlformats.org/drawingml/2006/main"/>
           <a:p xmlns:a="http://schemas.openxmlformats.org/drawingml/2006/main">
             <a:pPr algn="ctr">
+              <a:buNone/>
               <a:defRPr sz="1950" b="1">
                 <a:solidFill>
                   <a:srgbClr val="202321"/>
@@ -7326,7 +7441,7 @@
                 <a:ea typeface="Microsoft YaHei"/>
                 <a:cs typeface="Microsoft YaHei"/>
               </a:rPr>
-              <a:t>更新投影</a:t>
+              <a:t>更新场景</a:t>
             </a:r>
           </a:p>
         </p:txBody>
@@ -7365,6 +7480,7 @@
           <a:lstStyle xmlns:a="http://schemas.openxmlformats.org/drawingml/2006/main"/>
           <a:p xmlns:a="http://schemas.openxmlformats.org/drawingml/2006/main">
             <a:pPr algn="ctr">
+              <a:buNone/>
               <a:defRPr sz="1575" b="0">
                 <a:solidFill>
                   <a:srgbClr val="646B66"/>
@@ -7383,14 +7499,14 @@
                 <a:ea typeface="Microsoft YaHei"/>
                 <a:cs typeface="Microsoft YaHei"/>
               </a:rPr>
-              <a:t>继续对应原有身份</a:t>
+              <a:t>保留对象对应关系</a:t>
             </a:r>
           </a:p>
         </p:txBody>
       </p:sp>
       <p:cxnSp>
         <p:nvCxnSpPr>
-          <p:cNvPr id="57" name=""/>
+          <p:cNvPr id="93" name=""/>
           <p:cNvCxnSpPr>
             <a:stCxn xmlns:a="http://schemas.openxmlformats.org/drawingml/2006/main" id="6" idx="3"/>
             <a:endCxn xmlns:a="http://schemas.openxmlformats.org/drawingml/2006/main" id="12" idx="1"/>
@@ -7415,7 +7531,7 @@
       </p:cxnSp>
       <p:cxnSp>
         <p:nvCxnSpPr>
-          <p:cNvPr id="58" name=""/>
+          <p:cNvPr id="94" name=""/>
           <p:cNvCxnSpPr>
             <a:stCxn xmlns:a="http://schemas.openxmlformats.org/drawingml/2006/main" id="9" idx="3"/>
             <a:endCxn xmlns:a="http://schemas.openxmlformats.org/drawingml/2006/main" id="15" idx="1"/>
@@ -7504,6 +7620,7 @@
           <a:lstStyle xmlns:a="http://schemas.openxmlformats.org/drawingml/2006/main"/>
           <a:p xmlns:a="http://schemas.openxmlformats.org/drawingml/2006/main">
             <a:pPr algn="ctr">
+              <a:buNone/>
               <a:defRPr sz="1950" b="1">
                 <a:solidFill>
                   <a:srgbClr val="202321"/>
@@ -7561,6 +7678,7 @@
           <a:lstStyle xmlns:a="http://schemas.openxmlformats.org/drawingml/2006/main"/>
           <a:p xmlns:a="http://schemas.openxmlformats.org/drawingml/2006/main">
             <a:pPr algn="ctr">
+              <a:buNone/>
               <a:defRPr sz="1575" b="0">
                 <a:solidFill>
                   <a:srgbClr val="646B66"/>
@@ -7579,7 +7697,7 @@
                 <a:ea typeface="Microsoft YaHei"/>
                 <a:cs typeface="Microsoft YaHei"/>
               </a:rPr>
-              <a:t>相机 / 基础照明</a:t>
+              <a:t>相机与基础照明</a:t>
             </a:r>
           </a:p>
         </p:txBody>
@@ -7650,6 +7768,7 @@
           <a:lstStyle xmlns:a="http://schemas.openxmlformats.org/drawingml/2006/main"/>
           <a:p xmlns:a="http://schemas.openxmlformats.org/drawingml/2006/main">
             <a:pPr algn="ctr">
+              <a:buNone/>
               <a:defRPr sz="1950" b="1">
                 <a:solidFill>
                   <a:srgbClr val="202321"/>
@@ -7668,7 +7787,7 @@
                 <a:ea typeface="Microsoft YaHei"/>
                 <a:cs typeface="Microsoft YaHei"/>
               </a:rPr>
-              <a:t>更新后的场景</a:t>
+              <a:t>渲染设置</a:t>
             </a:r>
           </a:p>
         </p:txBody>
@@ -7707,6 +7826,7 @@
           <a:lstStyle xmlns:a="http://schemas.openxmlformats.org/drawingml/2006/main"/>
           <a:p xmlns:a="http://schemas.openxmlformats.org/drawingml/2006/main">
             <a:pPr algn="ctr">
+              <a:buNone/>
               <a:defRPr sz="1575" b="0">
                 <a:solidFill>
                   <a:srgbClr val="646B66"/>
@@ -7725,14 +7845,14 @@
                 <a:ea typeface="Microsoft YaHei"/>
                 <a:cs typeface="Microsoft YaHei"/>
               </a:rPr>
-              <a:t>沿用渲染路径</a:t>
+              <a:t>沿用相机与照明</a:t>
             </a:r>
           </a:p>
         </p:txBody>
       </p:sp>
       <p:cxnSp>
         <p:nvCxnSpPr>
-          <p:cNvPr id="65" name=""/>
+          <p:cNvPr id="101" name=""/>
           <p:cNvCxnSpPr>
             <a:stCxn xmlns:a="http://schemas.openxmlformats.org/drawingml/2006/main" id="12" idx="3"/>
             <a:endCxn xmlns:a="http://schemas.openxmlformats.org/drawingml/2006/main" id="20" idx="1"/>
@@ -7757,7 +7877,7 @@
       </p:cxnSp>
       <p:cxnSp>
         <p:nvCxnSpPr>
-          <p:cNvPr id="66" name=""/>
+          <p:cNvPr id="102" name=""/>
           <p:cNvCxnSpPr>
             <a:stCxn xmlns:a="http://schemas.openxmlformats.org/drawingml/2006/main" id="15" idx="3"/>
             <a:endCxn xmlns:a="http://schemas.openxmlformats.org/drawingml/2006/main" id="23" idx="1"/>
@@ -7846,6 +7966,7 @@
           <a:lstStyle xmlns:a="http://schemas.openxmlformats.org/drawingml/2006/main"/>
           <a:p xmlns:a="http://schemas.openxmlformats.org/drawingml/2006/main">
             <a:pPr algn="ctr">
+              <a:buNone/>
               <a:defRPr sz="1950" b="1">
                 <a:solidFill>
                   <a:srgbClr val="202321"/>
@@ -7903,6 +8024,7 @@
           <a:lstStyle xmlns:a="http://schemas.openxmlformats.org/drawingml/2006/main"/>
           <a:p xmlns:a="http://schemas.openxmlformats.org/drawingml/2006/main">
             <a:pPr algn="ctr">
+              <a:buNone/>
               <a:defRPr sz="1575" b="0">
                 <a:solidFill>
                   <a:srgbClr val="646B66"/>
@@ -7992,6 +8114,7 @@
           <a:lstStyle xmlns:a="http://schemas.openxmlformats.org/drawingml/2006/main"/>
           <a:p xmlns:a="http://schemas.openxmlformats.org/drawingml/2006/main">
             <a:pPr algn="ctr">
+              <a:buNone/>
               <a:defRPr sz="1950" b="1">
                 <a:solidFill>
                   <a:srgbClr val="202321"/>
@@ -8049,6 +8172,7 @@
           <a:lstStyle xmlns:a="http://schemas.openxmlformats.org/drawingml/2006/main"/>
           <a:p xmlns:a="http://schemas.openxmlformats.org/drawingml/2006/main">
             <a:pPr algn="ctr">
+              <a:buNone/>
               <a:defRPr sz="1575" b="0">
                 <a:solidFill>
                   <a:srgbClr val="646B66"/>
@@ -8074,7 +8198,7 @@
       </p:sp>
       <p:cxnSp>
         <p:nvCxnSpPr>
-          <p:cNvPr id="73" name=""/>
+          <p:cNvPr id="109" name=""/>
           <p:cNvCxnSpPr>
             <a:stCxn xmlns:a="http://schemas.openxmlformats.org/drawingml/2006/main" id="20" idx="3"/>
             <a:endCxn xmlns:a="http://schemas.openxmlformats.org/drawingml/2006/main" id="28" idx="1"/>
@@ -8099,7 +8223,7 @@
       </p:cxnSp>
       <p:cxnSp>
         <p:nvCxnSpPr>
-          <p:cNvPr id="74" name=""/>
+          <p:cNvPr id="110" name=""/>
           <p:cNvCxnSpPr>
             <a:stCxn xmlns:a="http://schemas.openxmlformats.org/drawingml/2006/main" id="23" idx="3"/>
             <a:endCxn xmlns:a="http://schemas.openxmlformats.org/drawingml/2006/main" id="31" idx="1"/>
@@ -8124,7 +8248,7 @@
       </p:cxnSp>
       <p:cxnSp>
         <p:nvCxnSpPr>
-          <p:cNvPr id="75" name=""/>
+          <p:cNvPr id="111" name=""/>
           <p:cNvCxnSpPr>
             <a:stCxn xmlns:a="http://schemas.openxmlformats.org/drawingml/2006/main" id="6" idx="2"/>
             <a:endCxn xmlns:a="http://schemas.openxmlformats.org/drawingml/2006/main" id="9" idx="0"/>
@@ -8181,6 +8305,7 @@
           <a:lstStyle xmlns:a="http://schemas.openxmlformats.org/drawingml/2006/main"/>
           <a:p xmlns:a="http://schemas.openxmlformats.org/drawingml/2006/main">
             <a:pPr algn="l">
+              <a:buNone/>
               <a:defRPr sz="1875" b="1">
                 <a:solidFill>
                   <a:srgbClr val="B74736"/>
@@ -8199,7 +8324,7 @@
                 <a:ea typeface="Microsoft YaHei"/>
                 <a:cs typeface="Microsoft YaHei"/>
               </a:rPr>
-              <a:t>一个显式投影动作</a:t>
+              <a:t>项目修改后，重新生成或更新 Blender 场景</a:t>
             </a:r>
           </a:p>
         </p:txBody>
@@ -8268,6 +8393,7 @@
           <a:lstStyle xmlns:a="http://schemas.openxmlformats.org/drawingml/2006/main"/>
           <a:p xmlns:a="http://schemas.openxmlformats.org/drawingml/2006/main">
             <a:pPr algn="l">
+              <a:buNone/>
               <a:defRPr sz="1875" b="0">
                 <a:solidFill>
                   <a:srgbClr val="202321"/>
@@ -8286,7 +8412,7 @@
                 <a:ea typeface="Microsoft YaHei"/>
                 <a:cs typeface="Microsoft YaHei"/>
               </a:rPr>
-              <a:t>两周交付：原生场景 + 修改前后的两张渲染图，项目身份保持对应</a:t>
+              <a:t>两周内完成场景文件和修改前后的两张渲染图，保持对象对应关系</a:t>
             </a:r>
           </a:p>
         </p:txBody>
@@ -8354,6 +8480,7 @@
           <a:lstStyle xmlns:a="http://schemas.openxmlformats.org/drawingml/2006/main"/>
           <a:p xmlns:a="http://schemas.openxmlformats.org/drawingml/2006/main">
             <a:pPr algn="l">
+              <a:buNone/>
               <a:defRPr sz="3300" b="1">
                 <a:solidFill>
                   <a:srgbClr val="202321"/>
@@ -8372,7 +8499,7 @@
                 <a:ea typeface="Microsoft YaHei"/>
                 <a:cs typeface="Microsoft YaHei"/>
               </a:rPr>
-              <a:t>Interaction · 现有工具的直接操作</a:t>
+              <a:t>Interaction / 连续建模的操作体验</a:t>
             </a:r>
           </a:p>
         </p:txBody>
@@ -8411,6 +8538,7 @@
           <a:lstStyle xmlns:a="http://schemas.openxmlformats.org/drawingml/2006/main"/>
           <a:p xmlns:a="http://schemas.openxmlformats.org/drawingml/2006/main">
             <a:pPr algn="l">
+              <a:buNone/>
               <a:defRPr sz="1950" b="0">
                 <a:solidFill>
                   <a:srgbClr val="646B66"/>
@@ -8429,7 +8557,7 @@
                 <a:ea typeface="Microsoft YaHei"/>
                 <a:cs typeface="Microsoft YaHei"/>
               </a:rPr>
-              <a:t>先完成 Move / Copy，再推进 Rotate、Scale / Mirror</a:t>
+              <a:t>移动、复制、旋转与缩放已合入 main，接下来完善连续操作与吸附</a:t>
             </a:r>
           </a:p>
         </p:txBody>
@@ -8498,6 +8626,7 @@
           <a:lstStyle xmlns:a="http://schemas.openxmlformats.org/drawingml/2006/main"/>
           <a:p xmlns:a="http://schemas.openxmlformats.org/drawingml/2006/main">
             <a:pPr algn="l">
+              <a:buNone/>
               <a:defRPr sz="1200" b="0">
                 <a:solidFill>
                   <a:srgbClr val="646B66"/>
@@ -8555,6 +8684,7 @@
           <a:lstStyle xmlns:a="http://schemas.openxmlformats.org/drawingml/2006/main"/>
           <a:p xmlns:a="http://schemas.openxmlformats.org/drawingml/2006/main">
             <a:pPr algn="r">
+              <a:buNone/>
               <a:defRPr sz="1350" b="0">
                 <a:solidFill>
                   <a:srgbClr val="646B66"/>
@@ -8644,6 +8774,7 @@
           <a:lstStyle xmlns:a="http://schemas.openxmlformats.org/drawingml/2006/main"/>
           <a:p xmlns:a="http://schemas.openxmlformats.org/drawingml/2006/main">
             <a:pPr algn="ctr">
+              <a:buNone/>
               <a:defRPr sz="1950" b="1">
                 <a:solidFill>
                   <a:srgbClr val="202321"/>
@@ -8701,6 +8832,7 @@
           <a:lstStyle xmlns:a="http://schemas.openxmlformats.org/drawingml/2006/main"/>
           <a:p xmlns:a="http://schemas.openxmlformats.org/drawingml/2006/main">
             <a:pPr algn="ctr">
+              <a:buNone/>
               <a:defRPr sz="1575" b="0">
                 <a:solidFill>
                   <a:srgbClr val="646B66"/>
@@ -8790,6 +8922,7 @@
           <a:lstStyle xmlns:a="http://schemas.openxmlformats.org/drawingml/2006/main"/>
           <a:p xmlns:a="http://schemas.openxmlformats.org/drawingml/2006/main">
             <a:pPr algn="ctr">
+              <a:buNone/>
               <a:defRPr sz="1950" b="1">
                 <a:solidFill>
                   <a:srgbClr val="202321"/>
@@ -8847,6 +8980,7 @@
           <a:lstStyle xmlns:a="http://schemas.openxmlformats.org/drawingml/2006/main"/>
           <a:p xmlns:a="http://schemas.openxmlformats.org/drawingml/2006/main">
             <a:pPr algn="ctr">
+              <a:buNone/>
               <a:defRPr sz="1575" b="0">
                 <a:solidFill>
                   <a:srgbClr val="646B66"/>
@@ -8872,7 +9006,7 @@
       </p:sp>
       <p:cxnSp>
         <p:nvCxnSpPr>
-          <p:cNvPr id="38" name=""/>
+          <p:cNvPr id="58" name=""/>
           <p:cNvCxnSpPr>
             <a:stCxn xmlns:a="http://schemas.openxmlformats.org/drawingml/2006/main" id="6" idx="3"/>
             <a:endCxn xmlns:a="http://schemas.openxmlformats.org/drawingml/2006/main" id="9" idx="1"/>
@@ -8961,6 +9095,7 @@
           <a:lstStyle xmlns:a="http://schemas.openxmlformats.org/drawingml/2006/main"/>
           <a:p xmlns:a="http://schemas.openxmlformats.org/drawingml/2006/main">
             <a:pPr algn="ctr">
+              <a:buNone/>
               <a:defRPr sz="1950" b="1">
                 <a:solidFill>
                   <a:srgbClr val="202321"/>
@@ -9018,6 +9153,7 @@
           <a:lstStyle xmlns:a="http://schemas.openxmlformats.org/drawingml/2006/main"/>
           <a:p xmlns:a="http://schemas.openxmlformats.org/drawingml/2006/main">
             <a:pPr algn="ctr">
+              <a:buNone/>
               <a:defRPr sz="1575" b="0">
                 <a:solidFill>
                   <a:srgbClr val="646B66"/>
@@ -9036,14 +9172,14 @@
                 <a:ea typeface="Microsoft YaHei"/>
                 <a:cs typeface="Microsoft YaHei"/>
               </a:rPr>
-              <a:t>一个草稿动作</a:t>
+              <a:t>确认本次草稿修改</a:t>
             </a:r>
           </a:p>
         </p:txBody>
       </p:sp>
       <p:cxnSp>
         <p:nvCxnSpPr>
-          <p:cNvPr id="42" name=""/>
+          <p:cNvPr id="62" name=""/>
           <p:cNvCxnSpPr>
             <a:stCxn xmlns:a="http://schemas.openxmlformats.org/drawingml/2006/main" id="9" idx="3"/>
             <a:endCxn xmlns:a="http://schemas.openxmlformats.org/drawingml/2006/main" id="13" idx="1"/>
@@ -9132,6 +9268,7 @@
           <a:lstStyle xmlns:a="http://schemas.openxmlformats.org/drawingml/2006/main"/>
           <a:p xmlns:a="http://schemas.openxmlformats.org/drawingml/2006/main">
             <a:pPr algn="ctr">
+              <a:buNone/>
               <a:defRPr sz="1950" b="1">
                 <a:solidFill>
                   <a:srgbClr val="B74736"/>
@@ -9189,6 +9326,7 @@
           <a:lstStyle xmlns:a="http://schemas.openxmlformats.org/drawingml/2006/main"/>
           <a:p xmlns:a="http://schemas.openxmlformats.org/drawingml/2006/main">
             <a:pPr algn="ctr">
+              <a:buNone/>
               <a:defRPr sz="1575" b="0">
                 <a:solidFill>
                   <a:srgbClr val="646B66"/>
@@ -9207,14 +9345,14 @@
                 <a:ea typeface="Microsoft YaHei"/>
                 <a:cs typeface="Microsoft YaHei"/>
               </a:rPr>
-              <a:t>一个验证候选</a:t>
+              <a:t>验证并保存候选</a:t>
             </a:r>
           </a:p>
         </p:txBody>
       </p:sp>
       <p:cxnSp>
         <p:nvCxnSpPr>
-          <p:cNvPr id="46" name=""/>
+          <p:cNvPr id="66" name=""/>
           <p:cNvCxnSpPr>
             <a:stCxn xmlns:a="http://schemas.openxmlformats.org/drawingml/2006/main" id="13" idx="3"/>
             <a:endCxn xmlns:a="http://schemas.openxmlformats.org/drawingml/2006/main" id="17" idx="1"/>
@@ -9301,6 +9439,7 @@
           <a:lstStyle xmlns:a="http://schemas.openxmlformats.org/drawingml/2006/main"/>
           <a:p xmlns:a="http://schemas.openxmlformats.org/drawingml/2006/main">
             <a:pPr algn="l">
+              <a:buNone/>
               <a:defRPr sz="2175" b="1">
                 <a:solidFill>
                   <a:srgbClr val="4E705E"/>
@@ -9319,7 +9458,7 @@
                 <a:ea typeface="Microsoft YaHei"/>
                 <a:cs typeface="Microsoft YaHei"/>
               </a:rPr>
-              <a:t>本地操作：指针移动时不调用模型</a:t>
+              <a:t>指针操作在本地即时预览</a:t>
             </a:r>
           </a:p>
         </p:txBody>
@@ -9358,6 +9497,7 @@
           <a:lstStyle xmlns:a="http://schemas.openxmlformats.org/drawingml/2006/main"/>
           <a:p xmlns:a="http://schemas.openxmlformats.org/drawingml/2006/main">
             <a:pPr algn="ctr">
+              <a:buNone/>
               <a:defRPr sz="1950" b="0">
                 <a:solidFill>
                   <a:srgbClr val="B74736"/>
@@ -9376,7 +9516,7 @@
                 <a:ea typeface="Microsoft YaHei"/>
                 <a:cs typeface="Microsoft YaHei"/>
               </a:rPr>
-              <a:t>按需执行与保存</a:t>
+              <a:t>按需同步与保存</a:t>
             </a:r>
           </a:p>
         </p:txBody>
@@ -9415,6 +9555,7 @@
           <a:lstStyle xmlns:a="http://schemas.openxmlformats.org/drawingml/2006/main"/>
           <a:p xmlns:a="http://schemas.openxmlformats.org/drawingml/2006/main">
             <a:pPr algn="l">
+              <a:buNone/>
               <a:defRPr sz="2025" b="0">
                 <a:solidFill>
                   <a:srgbClr val="202321"/>
@@ -9433,7 +9574,7 @@
                 <a:ea typeface="Microsoft YaHei"/>
                 <a:cs typeface="Microsoft YaHei"/>
               </a:rPr>
-              <a:t>先补当前工具需要的吸附保持与推断，再按实际测量决定索引优化</a:t>
+              <a:t>近期重点是吸附的稳定性和必要的推断，大场景优化依据实际延迟展开</a:t>
             </a:r>
           </a:p>
         </p:txBody>
@@ -9502,6 +9643,7 @@
           <a:lstStyle xmlns:a="http://schemas.openxmlformats.org/drawingml/2006/main"/>
           <a:p xmlns:a="http://schemas.openxmlformats.org/drawingml/2006/main">
             <a:pPr algn="l">
+              <a:buNone/>
               <a:defRPr sz="1875" b="0">
                 <a:solidFill>
                   <a:srgbClr val="202321"/>
@@ -9520,7 +9662,7 @@
                 <a:ea typeface="Microsoft YaHei"/>
                 <a:cs typeface="Microsoft YaHei"/>
               </a:rPr>
-              <a:t>两周交付：连续创建、移动和塑造一个简单体量模型，直接操作保持流畅</a:t>
+              <a:t>通过连续创建和修改一个简单体量模型，检查操作是否流畅、连贯</a:t>
             </a:r>
           </a:p>
         </p:txBody>
@@ -9588,6 +9730,7 @@
           <a:lstStyle xmlns:a="http://schemas.openxmlformats.org/drawingml/2006/main"/>
           <a:p xmlns:a="http://schemas.openxmlformats.org/drawingml/2006/main">
             <a:pPr algn="l">
+              <a:buNone/>
               <a:defRPr sz="3300" b="1">
                 <a:solidFill>
                   <a:srgbClr val="202321"/>
@@ -9606,7 +9749,7 @@
                 <a:ea typeface="Microsoft YaHei"/>
                 <a:cs typeface="Microsoft YaHei"/>
               </a:rPr>
-              <a:t>Backend · 先解释耗时，再减少轮次</a:t>
+              <a:t>Backend / 执行耗时与模型调用</a:t>
             </a:r>
           </a:p>
         </p:txBody>
@@ -9645,6 +9788,7 @@
           <a:lstStyle xmlns:a="http://schemas.openxmlformats.org/drawingml/2006/main"/>
           <a:p xmlns:a="http://schemas.openxmlformats.org/drawingml/2006/main">
             <a:pPr algn="l">
+              <a:buNone/>
               <a:defRPr sz="1950" b="0">
                 <a:solidFill>
                   <a:srgbClr val="646B66"/>
@@ -9663,7 +9807,7 @@
                 <a:ea typeface="Microsoft YaHei"/>
                 <a:cs typeface="Microsoft YaHei"/>
               </a:rPr>
-              <a:t>TurnTrace / MonkeyMonitor → ContextPack → DesignTransaction</a:t>
+              <a:t>记录设计任务各环节的耗时，据此判断哪些模型调用可以省去</a:t>
             </a:r>
           </a:p>
         </p:txBody>
@@ -9732,6 +9876,7 @@
           <a:lstStyle xmlns:a="http://schemas.openxmlformats.org/drawingml/2006/main"/>
           <a:p xmlns:a="http://schemas.openxmlformats.org/drawingml/2006/main">
             <a:pPr algn="l">
+              <a:buNone/>
               <a:defRPr sz="1200" b="0">
                 <a:solidFill>
                   <a:srgbClr val="646B66"/>
@@ -9789,6 +9934,7 @@
           <a:lstStyle xmlns:a="http://schemas.openxmlformats.org/drawingml/2006/main"/>
           <a:p xmlns:a="http://schemas.openxmlformats.org/drawingml/2006/main">
             <a:pPr algn="r">
+              <a:buNone/>
               <a:defRPr sz="1350" b="0">
                 <a:solidFill>
                   <a:srgbClr val="646B66"/>
@@ -9846,6 +9992,7 @@
           <a:lstStyle xmlns:a="http://schemas.openxmlformats.org/drawingml/2006/main"/>
           <a:p xmlns:a="http://schemas.openxmlformats.org/drawingml/2006/main">
             <a:pPr algn="l">
+              <a:buNone/>
               <a:defRPr sz="2325" b="1">
                 <a:solidFill>
                   <a:srgbClr val="B74736"/>
@@ -9864,7 +10011,7 @@
                 <a:ea typeface="Microsoft YaHei"/>
                 <a:cs typeface="Microsoft YaHei"/>
               </a:rPr>
-              <a:t>第一步：自动记录一整轮设计任务</a:t>
+              <a:t>近期工作：记录从请求到预览的完整过程</a:t>
             </a:r>
           </a:p>
         </p:txBody>
@@ -9935,6 +10082,7 @@
           <a:lstStyle xmlns:a="http://schemas.openxmlformats.org/drawingml/2006/main"/>
           <a:p xmlns:a="http://schemas.openxmlformats.org/drawingml/2006/main">
             <a:pPr algn="ctr">
+              <a:buNone/>
               <a:defRPr sz="1950" b="1">
                 <a:solidFill>
                   <a:srgbClr val="202321"/>
@@ -10024,6 +10172,7 @@
           <a:lstStyle xmlns:a="http://schemas.openxmlformats.org/drawingml/2006/main"/>
           <a:p xmlns:a="http://schemas.openxmlformats.org/drawingml/2006/main">
             <a:pPr algn="ctr">
+              <a:buNone/>
               <a:defRPr sz="1950" b="1">
                 <a:solidFill>
                   <a:srgbClr val="202321"/>
@@ -10049,7 +10198,7 @@
       </p:sp>
       <p:cxnSp>
         <p:nvCxnSpPr>
-          <p:cNvPr id="52" name=""/>
+          <p:cNvPr id="93" name=""/>
           <p:cNvCxnSpPr>
             <a:stCxn xmlns:a="http://schemas.openxmlformats.org/drawingml/2006/main" id="7" idx="3"/>
             <a:endCxn xmlns:a="http://schemas.openxmlformats.org/drawingml/2006/main" id="9" idx="1"/>
@@ -10138,6 +10287,7 @@
           <a:lstStyle xmlns:a="http://schemas.openxmlformats.org/drawingml/2006/main"/>
           <a:p xmlns:a="http://schemas.openxmlformats.org/drawingml/2006/main">
             <a:pPr algn="ctr">
+              <a:buNone/>
               <a:defRPr sz="1950" b="1">
                 <a:solidFill>
                   <a:srgbClr val="202321"/>
@@ -10163,7 +10313,7 @@
       </p:sp>
       <p:cxnSp>
         <p:nvCxnSpPr>
-          <p:cNvPr id="55" name=""/>
+          <p:cNvPr id="96" name=""/>
           <p:cNvCxnSpPr>
             <a:stCxn xmlns:a="http://schemas.openxmlformats.org/drawingml/2006/main" id="9" idx="3"/>
             <a:endCxn xmlns:a="http://schemas.openxmlformats.org/drawingml/2006/main" id="12" idx="1"/>
@@ -10252,6 +10402,7 @@
           <a:lstStyle xmlns:a="http://schemas.openxmlformats.org/drawingml/2006/main"/>
           <a:p xmlns:a="http://schemas.openxmlformats.org/drawingml/2006/main">
             <a:pPr algn="ctr">
+              <a:buNone/>
               <a:defRPr sz="1950" b="1">
                 <a:solidFill>
                   <a:srgbClr val="202321"/>
@@ -10277,7 +10428,7 @@
       </p:sp>
       <p:cxnSp>
         <p:nvCxnSpPr>
-          <p:cNvPr id="58" name=""/>
+          <p:cNvPr id="99" name=""/>
           <p:cNvCxnSpPr>
             <a:stCxn xmlns:a="http://schemas.openxmlformats.org/drawingml/2006/main" id="12" idx="3"/>
             <a:endCxn xmlns:a="http://schemas.openxmlformats.org/drawingml/2006/main" id="15" idx="1"/>
@@ -10366,6 +10517,7 @@
           <a:lstStyle xmlns:a="http://schemas.openxmlformats.org/drawingml/2006/main"/>
           <a:p xmlns:a="http://schemas.openxmlformats.org/drawingml/2006/main">
             <a:pPr algn="ctr">
+              <a:buNone/>
               <a:defRPr sz="1950" b="1">
                 <a:solidFill>
                   <a:srgbClr val="202321"/>
@@ -10391,7 +10543,7 @@
       </p:sp>
       <p:cxnSp>
         <p:nvCxnSpPr>
-          <p:cNvPr id="61" name=""/>
+          <p:cNvPr id="102" name=""/>
           <p:cNvCxnSpPr>
             <a:stCxn xmlns:a="http://schemas.openxmlformats.org/drawingml/2006/main" id="15" idx="3"/>
             <a:endCxn xmlns:a="http://schemas.openxmlformats.org/drawingml/2006/main" id="18" idx="1"/>
@@ -10480,6 +10632,7 @@
           <a:lstStyle xmlns:a="http://schemas.openxmlformats.org/drawingml/2006/main"/>
           <a:p xmlns:a="http://schemas.openxmlformats.org/drawingml/2006/main">
             <a:pPr algn="ctr">
+              <a:buNone/>
               <a:defRPr sz="1950" b="1">
                 <a:solidFill>
                   <a:srgbClr val="202321"/>
@@ -10505,7 +10658,7 @@
       </p:sp>
       <p:cxnSp>
         <p:nvCxnSpPr>
-          <p:cNvPr id="64" name=""/>
+          <p:cNvPr id="105" name=""/>
           <p:cNvCxnSpPr>
             <a:stCxn xmlns:a="http://schemas.openxmlformats.org/drawingml/2006/main" id="18" idx="3"/>
             <a:endCxn xmlns:a="http://schemas.openxmlformats.org/drawingml/2006/main" id="21" idx="1"/>
@@ -10562,6 +10715,7 @@
           <a:lstStyle xmlns:a="http://schemas.openxmlformats.org/drawingml/2006/main"/>
           <a:p xmlns:a="http://schemas.openxmlformats.org/drawingml/2006/main">
             <a:pPr algn="l">
+              <a:buNone/>
               <a:defRPr sz="2025" b="0">
                 <a:solidFill>
                   <a:srgbClr val="202321"/>
@@ -10580,7 +10734,7 @@
                 <a:ea typeface="Microsoft YaHei"/>
                 <a:cs typeface="Microsoft YaHei"/>
               </a:rPr>
-              <a:t>Monitor：水平瀑布图 · 语义活动树 · 关键路径 · 真实用量与费用口径</a:t>
+              <a:t>Monitor 展示各步骤耗时及其依赖关系，同时汇总用量与费用依据</a:t>
             </a:r>
           </a:p>
         </p:txBody>
@@ -10649,6 +10803,7 @@
           <a:lstStyle xmlns:a="http://schemas.openxmlformats.org/drawingml/2006/main"/>
           <a:p xmlns:a="http://schemas.openxmlformats.org/drawingml/2006/main">
             <a:pPr algn="l">
+              <a:buNone/>
               <a:defRPr sz="2175" b="1">
                 <a:solidFill>
                   <a:srgbClr val="202321"/>
@@ -10667,7 +10822,7 @@
                 <a:ea typeface="Microsoft YaHei"/>
                 <a:cs typeface="Microsoft YaHei"/>
               </a:rPr>
-              <a:t>第二步：用同一任务验证轮次减少</a:t>
+              <a:t>后续实验：用相同任务比较模型调用次数</a:t>
             </a:r>
           </a:p>
         </p:txBody>
@@ -10738,6 +10893,7 @@
           <a:lstStyle xmlns:a="http://schemas.openxmlformats.org/drawingml/2006/main"/>
           <a:p xmlns:a="http://schemas.openxmlformats.org/drawingml/2006/main">
             <a:pPr algn="ctr">
+              <a:buNone/>
               <a:defRPr sz="1950" b="1">
                 <a:solidFill>
                   <a:srgbClr val="202321"/>
@@ -10795,6 +10951,7 @@
           <a:lstStyle xmlns:a="http://schemas.openxmlformats.org/drawingml/2006/main"/>
           <a:p xmlns:a="http://schemas.openxmlformats.org/drawingml/2006/main">
             <a:pPr algn="ctr">
+              <a:buNone/>
               <a:defRPr sz="1575" b="0">
                 <a:solidFill>
                   <a:srgbClr val="646B66"/>
@@ -10813,7 +10970,7 @@
                 <a:ea typeface="Microsoft YaHei"/>
                 <a:cs typeface="Microsoft YaHei"/>
               </a:rPr>
-              <a:t>编译决策上下文</a:t>
+              <a:t>汇集本次判断所需信息</a:t>
             </a:r>
           </a:p>
         </p:txBody>
@@ -10884,6 +11041,7 @@
           <a:lstStyle xmlns:a="http://schemas.openxmlformats.org/drawingml/2006/main"/>
           <a:p xmlns:a="http://schemas.openxmlformats.org/drawingml/2006/main">
             <a:pPr algn="ctr">
+              <a:buNone/>
               <a:defRPr sz="1950" b="1">
                 <a:solidFill>
                   <a:srgbClr val="202321"/>
@@ -10941,6 +11099,7 @@
           <a:lstStyle xmlns:a="http://schemas.openxmlformats.org/drawingml/2006/main"/>
           <a:p xmlns:a="http://schemas.openxmlformats.org/drawingml/2006/main">
             <a:pPr algn="ctr">
+              <a:buNone/>
               <a:defRPr sz="1575" b="0">
                 <a:solidFill>
                   <a:srgbClr val="646B66"/>
@@ -10959,14 +11118,14 @@
                 <a:ea typeface="Microsoft YaHei"/>
                 <a:cs typeface="Microsoft YaHei"/>
               </a:rPr>
-              <a:t>输出设计事务</a:t>
+              <a:t>将修改组织为事务</a:t>
             </a:r>
           </a:p>
         </p:txBody>
       </p:sp>
       <p:cxnSp>
         <p:nvCxnSpPr>
-          <p:cNvPr id="74" name=""/>
+          <p:cNvPr id="115" name=""/>
           <p:cNvCxnSpPr>
             <a:stCxn xmlns:a="http://schemas.openxmlformats.org/drawingml/2006/main" id="27" idx="3"/>
             <a:endCxn xmlns:a="http://schemas.openxmlformats.org/drawingml/2006/main" id="30" idx="1"/>
@@ -11055,6 +11214,7 @@
           <a:lstStyle xmlns:a="http://schemas.openxmlformats.org/drawingml/2006/main"/>
           <a:p xmlns:a="http://schemas.openxmlformats.org/drawingml/2006/main">
             <a:pPr algn="ctr">
+              <a:buNone/>
               <a:defRPr sz="1950" b="1">
                 <a:solidFill>
                   <a:srgbClr val="202321"/>
@@ -11112,6 +11272,7 @@
           <a:lstStyle xmlns:a="http://schemas.openxmlformats.org/drawingml/2006/main"/>
           <a:p xmlns:a="http://schemas.openxmlformats.org/drawingml/2006/main">
             <a:pPr algn="ctr">
+              <a:buNone/>
               <a:defRPr sz="1575" b="0">
                 <a:solidFill>
                   <a:srgbClr val="646B66"/>
@@ -11130,14 +11291,14 @@
                 <a:ea typeface="Microsoft YaHei"/>
                 <a:cs typeface="Microsoft YaHei"/>
               </a:rPr>
-              <a:t>确定性执行并读回</a:t>
+              <a:t>执行事务并读取结果</a:t>
             </a:r>
           </a:p>
         </p:txBody>
       </p:sp>
       <p:cxnSp>
         <p:nvCxnSpPr>
-          <p:cNvPr id="78" name=""/>
+          <p:cNvPr id="119" name=""/>
           <p:cNvCxnSpPr>
             <a:stCxn xmlns:a="http://schemas.openxmlformats.org/drawingml/2006/main" id="30" idx="3"/>
             <a:endCxn xmlns:a="http://schemas.openxmlformats.org/drawingml/2006/main" id="34" idx="1"/>
@@ -11226,6 +11387,7 @@
           <a:lstStyle xmlns:a="http://schemas.openxmlformats.org/drawingml/2006/main"/>
           <a:p xmlns:a="http://schemas.openxmlformats.org/drawingml/2006/main">
             <a:pPr algn="ctr">
+              <a:buNone/>
               <a:defRPr sz="1950" b="1">
                 <a:solidFill>
                   <a:srgbClr val="202321"/>
@@ -11283,6 +11445,7 @@
           <a:lstStyle xmlns:a="http://schemas.openxmlformats.org/drawingml/2006/main"/>
           <a:p xmlns:a="http://schemas.openxmlformats.org/drawingml/2006/main">
             <a:pPr algn="ctr">
+              <a:buNone/>
               <a:defRPr sz="1575" b="0">
                 <a:solidFill>
                   <a:srgbClr val="646B66"/>
@@ -11301,14 +11464,14 @@
                 <a:ea typeface="Microsoft YaHei"/>
                 <a:cs typeface="Microsoft YaHei"/>
               </a:rPr>
-              <a:t>歧义时再请求判断</a:t>
+              <a:t>遇到歧义时请求判断</a:t>
             </a:r>
           </a:p>
         </p:txBody>
       </p:sp>
       <p:cxnSp>
         <p:nvCxnSpPr>
-          <p:cNvPr id="82" name=""/>
+          <p:cNvPr id="123" name=""/>
           <p:cNvCxnSpPr>
             <a:stCxn xmlns:a="http://schemas.openxmlformats.org/drawingml/2006/main" id="34" idx="3"/>
             <a:endCxn xmlns:a="http://schemas.openxmlformats.org/drawingml/2006/main" id="38" idx="1"/>
@@ -11394,6 +11557,7 @@
           <a:lstStyle xmlns:a="http://schemas.openxmlformats.org/drawingml/2006/main"/>
           <a:p xmlns:a="http://schemas.openxmlformats.org/drawingml/2006/main">
             <a:pPr algn="l">
+              <a:buNone/>
               <a:defRPr sz="3300" b="1">
                 <a:solidFill>
                   <a:srgbClr val="202321"/>
@@ -11412,7 +11576,7 @@
                 <a:ea typeface="Microsoft YaHei"/>
                 <a:cs typeface="Microsoft YaHei"/>
               </a:rPr>
-              <a:t>协作方式与当场分工</a:t>
+              <a:t>分工与协作安排</a:t>
             </a:r>
           </a:p>
         </p:txBody>
@@ -11451,6 +11615,7 @@
           <a:lstStyle xmlns:a="http://schemas.openxmlformats.org/drawingml/2006/main"/>
           <a:p xmlns:a="http://schemas.openxmlformats.org/drawingml/2006/main">
             <a:pPr algn="l">
+              <a:buNone/>
               <a:defRPr sz="1950" b="0">
                 <a:solidFill>
                   <a:srgbClr val="646B66"/>
@@ -11469,7 +11634,7 @@
                 <a:ea typeface="Microsoft YaHei"/>
                 <a:cs typeface="Microsoft YaHei"/>
               </a:rPr>
-              <a:t>先看谁在改什么，再开自己的 lane；共享接口先合，业务实现后分</a:t>
+              <a:t>各组从 main 建立独立分支，共用接口的修改单独提交</a:t>
             </a:r>
           </a:p>
         </p:txBody>
@@ -11538,6 +11703,7 @@
           <a:lstStyle xmlns:a="http://schemas.openxmlformats.org/drawingml/2006/main"/>
           <a:p xmlns:a="http://schemas.openxmlformats.org/drawingml/2006/main">
             <a:pPr algn="l">
+              <a:buNone/>
               <a:defRPr sz="1200" b="0">
                 <a:solidFill>
                   <a:srgbClr val="646B66"/>
@@ -11595,6 +11761,7 @@
           <a:lstStyle xmlns:a="http://schemas.openxmlformats.org/drawingml/2006/main"/>
           <a:p xmlns:a="http://schemas.openxmlformats.org/drawingml/2006/main">
             <a:pPr algn="r">
+              <a:buNone/>
               <a:defRPr sz="1350" b="0">
                 <a:solidFill>
                   <a:srgbClr val="646B66"/>
@@ -11684,6 +11851,7 @@
           <a:lstStyle xmlns:a="http://schemas.openxmlformats.org/drawingml/2006/main"/>
           <a:p xmlns:a="http://schemas.openxmlformats.org/drawingml/2006/main">
             <a:pPr algn="ctr">
+              <a:buNone/>
               <a:defRPr sz="1950" b="1">
                 <a:solidFill>
                   <a:srgbClr val="202321"/>
@@ -11702,7 +11870,7 @@
                 <a:ea typeface="Microsoft YaHei"/>
                 <a:cs typeface="Microsoft YaHei"/>
               </a:rPr>
-              <a:t>查看现有任务</a:t>
+              <a:t>了解现有工作</a:t>
             </a:r>
           </a:p>
         </p:txBody>
@@ -11741,6 +11909,7 @@
           <a:lstStyle xmlns:a="http://schemas.openxmlformats.org/drawingml/2006/main"/>
           <a:p xmlns:a="http://schemas.openxmlformats.org/drawingml/2006/main">
             <a:pPr algn="ctr">
+              <a:buNone/>
               <a:defRPr sz="1575" b="0">
                 <a:solidFill>
                   <a:srgbClr val="646B66"/>
@@ -11759,7 +11928,7 @@
                 <a:ea typeface="Microsoft YaHei"/>
                 <a:cs typeface="Microsoft YaHei"/>
               </a:rPr>
-              <a:t>owner / contract</a:t>
+              <a:t>模块职责与接口</a:t>
             </a:r>
           </a:p>
         </p:txBody>
@@ -11830,6 +11999,7 @@
           <a:lstStyle xmlns:a="http://schemas.openxmlformats.org/drawingml/2006/main"/>
           <a:p xmlns:a="http://schemas.openxmlformats.org/drawingml/2006/main">
             <a:pPr algn="ctr">
+              <a:buNone/>
               <a:defRPr sz="1950" b="1">
                 <a:solidFill>
                   <a:srgbClr val="202321"/>
@@ -11848,7 +12018,7 @@
                 <a:ea typeface="Microsoft YaHei"/>
                 <a:cs typeface="Microsoft YaHei"/>
               </a:rPr>
-              <a:t>独立 lane</a:t>
+              <a:t>建立独立分支</a:t>
             </a:r>
           </a:p>
         </p:txBody>
@@ -11887,6 +12057,7 @@
           <a:lstStyle xmlns:a="http://schemas.openxmlformats.org/drawingml/2006/main"/>
           <a:p xmlns:a="http://schemas.openxmlformats.org/drawingml/2006/main">
             <a:pPr algn="ctr">
+              <a:buNone/>
               <a:defRPr sz="1575" b="0">
                 <a:solidFill>
                   <a:srgbClr val="646B66"/>
@@ -11905,14 +12076,14 @@
                 <a:ea typeface="Microsoft YaHei"/>
                 <a:cs typeface="Microsoft YaHei"/>
               </a:rPr>
-              <a:t>branch / worktree</a:t>
+              <a:t>分开保存各组修改</a:t>
             </a:r>
           </a:p>
         </p:txBody>
       </p:sp>
       <p:cxnSp>
         <p:nvCxnSpPr>
-          <p:cNvPr id="40" name=""/>
+          <p:cNvPr id="60" name=""/>
           <p:cNvCxnSpPr>
             <a:stCxn xmlns:a="http://schemas.openxmlformats.org/drawingml/2006/main" id="6" idx="3"/>
             <a:endCxn xmlns:a="http://schemas.openxmlformats.org/drawingml/2006/main" id="9" idx="1"/>
@@ -12001,6 +12172,7 @@
           <a:lstStyle xmlns:a="http://schemas.openxmlformats.org/drawingml/2006/main"/>
           <a:p xmlns:a="http://schemas.openxmlformats.org/drawingml/2006/main">
             <a:pPr algn="ctr">
+              <a:buNone/>
               <a:defRPr sz="1950" b="1">
                 <a:solidFill>
                   <a:srgbClr val="202321"/>
@@ -12019,7 +12191,7 @@
                 <a:ea typeface="Microsoft YaHei"/>
                 <a:cs typeface="Microsoft YaHei"/>
               </a:rPr>
-              <a:t>一个小 PR</a:t>
+              <a:t>提交 PR</a:t>
             </a:r>
           </a:p>
         </p:txBody>
@@ -12058,6 +12230,7 @@
           <a:lstStyle xmlns:a="http://schemas.openxmlformats.org/drawingml/2006/main"/>
           <a:p xmlns:a="http://schemas.openxmlformats.org/drawingml/2006/main">
             <a:pPr algn="ctr">
+              <a:buNone/>
               <a:defRPr sz="1575" b="0">
                 <a:solidFill>
                   <a:srgbClr val="646B66"/>
@@ -12076,14 +12249,14 @@
                 <a:ea typeface="Microsoft YaHei"/>
                 <a:cs typeface="Microsoft YaHei"/>
               </a:rPr>
-              <a:t>明确测试与接口</a:t>
+              <a:t>说明修改与检查结果</a:t>
             </a:r>
           </a:p>
         </p:txBody>
       </p:sp>
       <p:cxnSp>
         <p:nvCxnSpPr>
-          <p:cNvPr id="44" name=""/>
+          <p:cNvPr id="64" name=""/>
           <p:cNvCxnSpPr>
             <a:stCxn xmlns:a="http://schemas.openxmlformats.org/drawingml/2006/main" id="9" idx="3"/>
             <a:endCxn xmlns:a="http://schemas.openxmlformats.org/drawingml/2006/main" id="13" idx="1"/>
@@ -12172,6 +12345,7 @@
           <a:lstStyle xmlns:a="http://schemas.openxmlformats.org/drawingml/2006/main"/>
           <a:p xmlns:a="http://schemas.openxmlformats.org/drawingml/2006/main">
             <a:pPr algn="ctr">
+              <a:buNone/>
               <a:defRPr sz="1950" b="1">
                 <a:solidFill>
                   <a:srgbClr val="202321"/>
@@ -12229,6 +12403,7 @@
           <a:lstStyle xmlns:a="http://schemas.openxmlformats.org/drawingml/2006/main"/>
           <a:p xmlns:a="http://schemas.openxmlformats.org/drawingml/2006/main">
             <a:pPr algn="ctr">
+              <a:buNone/>
               <a:defRPr sz="1575" b="0">
                 <a:solidFill>
                   <a:srgbClr val="646B66"/>
@@ -12247,14 +12422,14 @@
                 <a:ea typeface="Microsoft YaHei"/>
                 <a:cs typeface="Microsoft YaHei"/>
               </a:rPr>
-              <a:t>共同的集成事实</a:t>
+              <a:t>作为后续工作的起点</a:t>
             </a:r>
           </a:p>
         </p:txBody>
       </p:sp>
       <p:cxnSp>
         <p:nvCxnSpPr>
-          <p:cNvPr id="48" name=""/>
+          <p:cNvPr id="68" name=""/>
           <p:cNvCxnSpPr>
             <a:stCxn xmlns:a="http://schemas.openxmlformats.org/drawingml/2006/main" id="13" idx="3"/>
             <a:endCxn xmlns:a="http://schemas.openxmlformats.org/drawingml/2006/main" id="17" idx="1"/>
@@ -12311,6 +12486,7 @@
           <a:lstStyle xmlns:a="http://schemas.openxmlformats.org/drawingml/2006/main"/>
           <a:p xmlns:a="http://schemas.openxmlformats.org/drawingml/2006/main">
             <a:pPr algn="l">
+              <a:buNone/>
               <a:defRPr sz="2475" b="1">
                 <a:solidFill>
                   <a:srgbClr val="B74736"/>
@@ -12329,7 +12505,7 @@
                 <a:ea typeface="Microsoft YaHei"/>
                 <a:cs typeface="Microsoft YaHei"/>
               </a:rPr>
-              <a:t>每条线离会前确定</a:t>
+              <a:t>会议需确定的分工</a:t>
             </a:r>
           </a:p>
         </p:txBody>
@@ -12368,6 +12544,7 @@
           <a:lstStyle xmlns:a="http://schemas.openxmlformats.org/drawingml/2006/main"/>
           <a:p xmlns:a="http://schemas.openxmlformats.org/drawingml/2006/main">
             <a:pPr algn="l">
+              <a:buNone/>
               <a:defRPr sz="2025" b="1">
                 <a:solidFill>
                   <a:srgbClr val="202321"/>
@@ -12386,7 +12563,7 @@
                 <a:ea typeface="Microsoft YaHei"/>
                 <a:cs typeface="Microsoft YaHei"/>
               </a:rPr>
-              <a:t>谁负责</a:t>
+              <a:t>负责人</a:t>
             </a:r>
           </a:p>
         </p:txBody>
@@ -12425,6 +12602,7 @@
           <a:lstStyle xmlns:a="http://schemas.openxmlformats.org/drawingml/2006/main"/>
           <a:p xmlns:a="http://schemas.openxmlformats.org/drawingml/2006/main">
             <a:pPr algn="l">
+              <a:buNone/>
               <a:defRPr sz="2025" b="0">
                 <a:solidFill>
                   <a:srgbClr val="202321"/>
@@ -12443,7 +12621,7 @@
                 <a:ea typeface="Microsoft YaHei"/>
                 <a:cs typeface="Microsoft YaHei"/>
               </a:rPr>
-              <a:t>负责人 + 对应 issue / lane</a:t>
+              <a:t>认领的方向及对应任务</a:t>
             </a:r>
           </a:p>
         </p:txBody>
@@ -12482,6 +12660,7 @@
           <a:lstStyle xmlns:a="http://schemas.openxmlformats.org/drawingml/2006/main"/>
           <a:p xmlns:a="http://schemas.openxmlformats.org/drawingml/2006/main">
             <a:pPr algn="l">
+              <a:buNone/>
               <a:defRPr sz="2025" b="1">
                 <a:solidFill>
                   <a:srgbClr val="202321"/>
@@ -12500,7 +12679,7 @@
                 <a:ea typeface="Microsoft YaHei"/>
                 <a:cs typeface="Microsoft YaHei"/>
               </a:rPr>
-              <a:t>先交付什么</a:t>
+              <a:t>近期成果</a:t>
             </a:r>
           </a:p>
         </p:txBody>
@@ -12539,6 +12718,7 @@
           <a:lstStyle xmlns:a="http://schemas.openxmlformats.org/drawingml/2006/main"/>
           <a:p xmlns:a="http://schemas.openxmlformats.org/drawingml/2006/main">
             <a:pPr algn="l">
+              <a:buNone/>
               <a:defRPr sz="2025" b="0">
                 <a:solidFill>
                   <a:srgbClr val="202321"/>
@@ -12557,7 +12737,7 @@
                 <a:ea typeface="Microsoft YaHei"/>
                 <a:cs typeface="Microsoft YaHei"/>
               </a:rPr>
-              <a:t>首个 PR / 研究产物 + 文件边界</a:t>
+              <a:t>首个 PR 或研究材料，涉及的文件与模块</a:t>
             </a:r>
           </a:p>
         </p:txBody>
@@ -12596,6 +12776,7 @@
           <a:lstStyle xmlns:a="http://schemas.openxmlformats.org/drawingml/2006/main"/>
           <a:p xmlns:a="http://schemas.openxmlformats.org/drawingml/2006/main">
             <a:pPr algn="l">
+              <a:buNone/>
               <a:defRPr sz="2025" b="1">
                 <a:solidFill>
                   <a:srgbClr val="202321"/>
@@ -12614,7 +12795,7 @@
                 <a:ea typeface="Microsoft YaHei"/>
                 <a:cs typeface="Microsoft YaHei"/>
               </a:rPr>
-              <a:t>如何判断完成</a:t>
+              <a:t>完成条件</a:t>
             </a:r>
           </a:p>
         </p:txBody>
@@ -12653,6 +12834,7 @@
           <a:lstStyle xmlns:a="http://schemas.openxmlformats.org/drawingml/2006/main"/>
           <a:p xmlns:a="http://schemas.openxmlformats.org/drawingml/2006/main">
             <a:pPr algn="l">
+              <a:buNone/>
               <a:defRPr sz="2025" b="0">
                 <a:solidFill>
                   <a:srgbClr val="202321"/>
@@ -12671,7 +12853,7 @@
                 <a:ea typeface="Microsoft YaHei"/>
                 <a:cs typeface="Microsoft YaHei"/>
               </a:rPr>
-              <a:t>测试 / 基准 + 依赖与阻塞</a:t>
+              <a:t>检查方法，以及需要其他组先完成的工作</a:t>
             </a:r>
           </a:p>
         </p:txBody>
@@ -12710,6 +12892,7 @@
           <a:lstStyle xmlns:a="http://schemas.openxmlformats.org/drawingml/2006/main"/>
           <a:p xmlns:a="http://schemas.openxmlformats.org/drawingml/2006/main">
             <a:pPr algn="l">
+              <a:buNone/>
               <a:defRPr sz="1500" b="0">
                 <a:solidFill>
                   <a:srgbClr val="646B66"/>
@@ -12728,7 +12911,7 @@
                 <a:ea typeface="Microsoft YaHei"/>
                 <a:cs typeface="Microsoft YaHei"/>
               </a:rPr>
-              <a:t>后续方向：Board 协作、桌面完整打包、恢复深化与 Diagram / Fab 扩展</a:t>
+              <a:t>后续工作：Board 协作、桌面完整打包、任务恢复及 Diagram / Fab 扩展</a:t>
             </a:r>
           </a:p>
         </p:txBody>

</xml_diff>